<commit_message>
Calibration against English WordNet under identical processing; DEX without function words
The DEX Kernel is about twice and its MinSet about four times the WordNet values
obtained with the same procedure; removing function words changes little.
Paper, abstract, slides and README updated; download script for the
cross-linguistic Wiktionary comparison.

Co-Authored-By: Claude Opus 5.5 <noreply@anthropic.com>
</commit_message>
<xml_diff>
--- a/slides/HiddenCore_ConsILR2026.pptx
+++ b/slides/HiddenCore_ConsILR2026.pptx
@@ -865,7 +865,7 @@
           <a:lstStyle/>
           <a:p>
             <a:r>
-              <a:t>Concluzia: o treime din DEX formează nucleul; aproximativ un cuvânt din zece trebuie știut dinainte. De zece ori mai mult decât în engleză, din cauza definițiilor prin sinonim. Mulțumesc!</a:t>
+              <a:t>Concluzia: o treime din DEX formează nucleul; aproximativ un cuvânt din zece trebuie știut dinainte. De circa patru ori mai mult decât WordNet procesat la fel, din cauza definițiilor prin sinonim. Mulțumesc!</a:t>
             </a:r>
           </a:p>
         </p:txBody>
@@ -1215,7 +1215,7 @@
           <a:lstStyle/>
           <a:p>
             <a:r>
-              <a:t>Nucleul DEX are 33% din cuvinte, de trei până la cinci ori mai mult decât în engleză. Setul minim: între 6,193 și 6,325 cuvinte, adică aproape zece procente, de zece ori mai mult decât în engleză. Intervalul e calculat exact, cu programare liniară în numere întregi.</a:t>
+              <a:t>Nucleul DEX are 33% din cuvinte, de circa două ori mai mult decât WordNet-ul englez procesat la fel. Setul minim: între 6,193 și 6,325 cuvinte, adică aproape zece procente, de circa patru ori mai mult decât WordNet procesat la fel (și de zece ori față de cifrele publicate pentru engleză). Limitele sunt demonstrate cu programare liniară în numere întregi.</a:t>
             </a:r>
           </a:p>
         </p:txBody>
@@ -7946,7 +7946,7 @@
                 </a:solidFill>
                 <a:latin typeface="Calibri"/>
               </a:rPr>
-              <a:t>About ten times the English proportion, mainly because the DEX defines words by synonyms.</a:t>
+              <a:t>About four times the English WordNet under the same procedure, mainly because the DEX defines words by synonyms.</a:t>
             </a:r>
           </a:p>
           <a:p>
@@ -10489,7 +10489,7 @@
         <p:spPr>
           <a:xfrm>
             <a:off x="640080" y="1737360"/>
-            <a:ext cx="6675120" cy="3017154"/>
+            <a:ext cx="6675120" cy="3022502"/>
           </a:xfrm>
           <a:prstGeom prst="rect">
             <a:avLst/>

</xml_diff>

<commit_message>
Cross-linguistic comparison in the paper (section 4.2, figure 5, table 2), abstract and slides
Abstract merges the co-author's framing with the current results. Paper now 12 pages.

Co-Authored-By: Claude Opus 5.5 <noreply@anthropic.com>
</commit_message>
<xml_diff>
--- a/slides/HiddenCore_ConsILR2026.pptx
+++ b/slides/HiddenCore_ConsILR2026.pptx
@@ -19,6 +19,7 @@
     <p:sldId id="267" r:id="rId19"/>
     <p:sldId id="268" r:id="rId20"/>
     <p:sldId id="269" r:id="rId21"/>
+    <p:sldId id="270" r:id="rId22"/>
   </p:sldIdLst>
   <p:sldSz cx="12191695" cy="6858000" type="screen4x3"/>
   <p:notesSz cx="6858000" cy="9144000"/>
@@ -585,7 +586,7 @@
           <a:lstStyle/>
           <a:p>
             <a:r>
-              <a:t>Exemplele lui Graur. A exclus arbore pentru că e în concurență cu copac; dar DEX-ul folosește arbore aproape de două ori mai des decât copac ca termen definitoriu. Preferințele dicționarului nu coincid cu uzul descris de Graur, și asta e o observație interesantă despre metalimbajul lexicografic.</a:t>
+              <a:t>Este nucleul real lingvistic? 98% din lista Swadesh și 95% din lista lui Graur sunt în nucleu, față de 33% la întâmplare. Lista Swadesh este lista standard de circa 200 de sensuri de bază folosită în lingvistica comparată. Cuvintele pe care Graur le considera cele mai sigure sunt cele mai centrale: 97% în nucleu și 49% în setul minim; cele două cercuri mai largi diferă puțin între ele.</a:t>
             </a:r>
           </a:p>
         </p:txBody>
@@ -655,7 +656,7 @@
           <a:lstStyle/>
           <a:p>
             <a:r>
-              <a:t>Dar nu e identitate. Cuvintele cu care DEX-ul își scrie definițiile sunt în mare parte împrumuturi savante franceze. Nucleul lui Graur e unul al stabilității; al dicționarului, unul al muncii de definire. Cuvintele rurale ale lui Graur sunt definite, dar nu definesc nimic.</a:t>
+              <a:t>Exemplele lui Graur. A exclus arbore pentru că e în concurență cu copac; dar DEX-ul folosește arbore aproape de două ori mai des decât copac ca termen definitoriu. Preferințele dicționarului nu coincid cu uzul descris de Graur, și asta e o observație interesantă despre metalimbajul lexicografic.</a:t>
             </a:r>
           </a:p>
         </p:txBody>
@@ -725,7 +726,7 @@
           <a:lstStyle/>
           <a:p>
             <a:r>
-              <a:t>Trei lucruri pentru lingviști: o hartă a circularității pentru lexicografi, un test cantitativ al unei idei clasice și o rețetă de folosire a AI-ului ca instrument verificabil.</a:t>
+              <a:t>Dar nu e identitate. Cuvintele cu care DEX-ul își scrie definițiile sunt în mare parte împrumuturi savante franceze. Nucleul lui Graur e unul al stabilității; al dicționarului, unul al muncii de definire. Cuvintele rurale ale lui Graur sunt definite, dar nu definesc nimic.</a:t>
             </a:r>
           </a:p>
         </p:txBody>
@@ -795,7 +796,7 @@
           <a:lstStyle/>
           <a:p>
             <a:r>
-              <a:t>Cât de siguri suntem: foarte siguri pe circularitate și pe concentrarea listelor de experți în nucleu; bine pe mărimea setului minim și pe poziția cuvintelor celor mai sigure ale lui Graur; orientativ pe contrastul etimologic. Limita principală: un singur dicționar.</a:t>
+              <a:t>Trei lucruri pentru lingviști: o hartă a circularității pentru lexicografi, un test cantitativ al unei idei clasice și o rețetă de folosire a AI-ului ca instrument verificabil.</a:t>
             </a:r>
           </a:p>
         </p:txBody>
@@ -865,6 +866,76 @@
           <a:lstStyle/>
           <a:p>
             <a:r>
+              <a:t>Cât de siguri suntem: foarte siguri pe circularitate și pe concentrarea listelor de experți în nucleu; bine pe mărimea setului minim și pe poziția cuvintelor celor mai sigure ale lui Graur; orientativ pe contrastul etimologic. Limita principală: un singur dicționar.</a:t>
+            </a:r>
+          </a:p>
+        </p:txBody>
+      </p:sp>
+      <p:sp>
+        <p:nvSpPr>
+          <p:cNvPr id="4" name="Slide Number Placeholder 3"/>
+          <p:cNvSpPr>
+            <a:spLocks noGrp="1"/>
+          </p:cNvSpPr>
+          <p:nvPr>
+            <p:ph type="sldNum" idx="5" sz="quarter"/>
+          </p:nvPr>
+        </p:nvSpPr>
+        <p:spPr/>
+      </p:sp>
+    </p:spTree>
+  </p:cSld>
+  <p:clrMapOvr>
+    <a:masterClrMapping/>
+  </p:clrMapOvr>
+</p:notes>
+</file>
+
+<file path=ppt/notesSlides/notesSlide15.xml><?xml version="1.0" encoding="utf-8"?>
+<p:notes xmlns:a="http://schemas.openxmlformats.org/drawingml/2006/main" xmlns:p="http://schemas.openxmlformats.org/presentationml/2006/main" xmlns:r="http://schemas.openxmlformats.org/officeDocument/2006/relationships">
+  <p:cSld>
+    <p:spTree>
+      <p:nvGrpSpPr>
+        <p:cNvPr id="1" name=""/>
+        <p:cNvGrpSpPr/>
+        <p:nvPr/>
+      </p:nvGrpSpPr>
+      <p:grpSpPr>
+        <a:xfrm>
+          <a:off x="0" y="0"/>
+          <a:ext cx="0" cy="0"/>
+          <a:chOff x="0" y="0"/>
+          <a:chExt cx="0" cy="0"/>
+        </a:xfrm>
+      </p:grpSpPr>
+      <p:sp>
+        <p:nvSpPr>
+          <p:cNvPr id="2" name="Slide Image Placeholder 1"/>
+          <p:cNvSpPr>
+            <a:spLocks noGrp="1"/>
+          </p:cNvSpPr>
+          <p:nvPr>
+            <p:ph type="sldImg" idx="2"/>
+          </p:nvPr>
+        </p:nvSpPr>
+        <p:spPr/>
+      </p:sp>
+      <p:sp>
+        <p:nvSpPr>
+          <p:cNvPr id="3" name="Notes Placeholder 2"/>
+          <p:cNvSpPr>
+            <a:spLocks noGrp="1"/>
+          </p:cNvSpPr>
+          <p:nvPr>
+            <p:ph type="body" idx="3" sz="quarter"/>
+          </p:nvPr>
+        </p:nvSpPr>
+        <p:spPr/>
+        <p:txBody>
+          <a:bodyPr/>
+          <a:lstStyle/>
+          <a:p>
+            <a:r>
               <a:t>Concluzia: o treime din DEX formează nucleul; aproximativ un cuvânt din zece trebuie știut dinainte. De circa patru ori mai mult decât WordNet procesat la fel, din cauza definițiilor prin sinonim. Mulțumesc!</a:t>
             </a:r>
           </a:p>
@@ -1285,7 +1356,7 @@
           <a:lstStyle/>
           <a:p>
             <a:r>
-              <a:t>De ce? Pentru că DEX-ul definește prin sinonime. Aproape nouă mii de perechi (8.761) se definesc reciproc. Fiecare pereche te obligă să știi dinainte unul dintre cuvinte. Nu sunt greșeli: e un stil de definire. Graur însuși observase concurența arbore–copac.</a:t>
+              <a:t>Am aplicat exact aceeași procedură pe WordNet și pe Wiktionary-urile a 11 limbi. Peste tot, setul minim ocupă 10–16% din nucleu; în DEX ocupă 28%. Wiktionary-ul românesc seamănă cu DEX-ul, dar 70% din definițiile lui sunt copiate din DEX. Deci nucleul mare ține de felul în care definește DEX-ul, nu de faptul că româna e limbă romanică.</a:t>
             </a:r>
           </a:p>
         </p:txBody>
@@ -1355,7 +1426,7 @@
           <a:lstStyle/>
           <a:p>
             <a:r>
-              <a:t>Refacem tot fără AI, în două feluri. Rezultatul rămâne același: nucleu 29–36%, MinSet 7.5–10.9%. Deci concluzia nu e un artefact al modelului.</a:t>
+              <a:t>De ce? Pentru că DEX-ul definește prin sinonime. Aproape nouă mii de perechi (8.761) se definesc reciproc. Fiecare pereche te obligă să știi dinainte unul dintre cuvinte. Nu sunt greșeli: e un stil de definire. Graur însuși observase concurența arbore–copac.</a:t>
             </a:r>
           </a:p>
         </p:txBody>
@@ -1425,7 +1496,7 @@
           <a:lstStyle/>
           <a:p>
             <a:r>
-              <a:t>Este nucleul real lingvistic? 98% din lista Swadesh și 95% din lista lui Graur sunt în nucleu, față de 33% la întâmplare. Lista Swadesh este lista standard de circa 200 de sensuri de bază folosită în lingvistica comparată. Cuvintele pe care Graur le considera cele mai sigure sunt cele mai centrale: 97% în nucleu și 49% în setul minim; cele două cercuri mai largi diferă puțin între ele.</a:t>
+              <a:t>Refacem tot fără AI, în două feluri. Rezultatul rămâne același: nucleu 29–36%, MinSet 7.5–10.9%. Deci concluzia nu e un artefact al modelului.</a:t>
             </a:r>
           </a:p>
         </p:txBody>
@@ -4621,6 +4692,337 @@
 </file>
 
 <file path=ppt/slides/slide10.xml><?xml version="1.0" encoding="utf-8"?>
+<p:sld xmlns:a="http://schemas.openxmlformats.org/drawingml/2006/main" xmlns:p="http://schemas.openxmlformats.org/presentationml/2006/main" xmlns:r="http://schemas.openxmlformats.org/officeDocument/2006/relationships">
+  <p:cSld>
+    <p:bg>
+      <p:bgPr>
+        <a:solidFill>
+          <a:srgbClr val="FCFCFB"/>
+        </a:solidFill>
+        <a:effectLst/>
+      </p:bgPr>
+    </p:bg>
+    <p:spTree>
+      <p:nvGrpSpPr>
+        <p:cNvPr id="1" name=""/>
+        <p:cNvGrpSpPr/>
+        <p:nvPr/>
+      </p:nvGrpSpPr>
+      <p:grpSpPr/>
+      <p:pic>
+        <p:nvPicPr>
+          <p:cNvPr id="2" name="Picture 1" descr="logo_consilr.png"/>
+          <p:cNvPicPr>
+            <a:picLocks noChangeAspect="1"/>
+          </p:cNvPicPr>
+          <p:nvPr/>
+        </p:nvPicPr>
+        <p:blipFill>
+          <a:blip r:embed="rId2"/>
+          <a:stretch>
+            <a:fillRect/>
+          </a:stretch>
+        </p:blipFill>
+        <p:spPr>
+          <a:xfrm>
+            <a:off x="10591495" y="256032"/>
+            <a:ext cx="1311965" cy="502920"/>
+          </a:xfrm>
+          <a:prstGeom prst="rect">
+            <a:avLst/>
+          </a:prstGeom>
+        </p:spPr>
+      </p:pic>
+      <p:sp>
+        <p:nvSpPr>
+          <p:cNvPr id="3" name="TextBox 2"/>
+          <p:cNvSpPr txBox="1"/>
+          <p:nvPr/>
+        </p:nvSpPr>
+        <p:spPr>
+          <a:xfrm>
+            <a:off x="640080" y="320040"/>
+            <a:ext cx="9144000" cy="365760"/>
+          </a:xfrm>
+          <a:prstGeom prst="rect">
+            <a:avLst/>
+          </a:prstGeom>
+          <a:noFill/>
+        </p:spPr>
+        <p:txBody>
+          <a:bodyPr wrap="square" anchor="t" lIns="45720" rIns="45720">
+            <a:spAutoFit/>
+          </a:bodyPr>
+          <a:lstStyle/>
+          <a:p>
+            <a:pPr algn="l">
+              <a:spcAft>
+                <a:spcPts val="585"/>
+              </a:spcAft>
+            </a:pPr>
+            <a:r>
+              <a:rPr sz="1300" b="1">
+                <a:solidFill>
+                  <a:srgbClr val="2A78D6"/>
+                </a:solidFill>
+                <a:latin typeface="Calibri"/>
+              </a:rPr>
+              <a:t>RESULT 3</a:t>
+            </a:r>
+          </a:p>
+        </p:txBody>
+      </p:sp>
+      <p:sp>
+        <p:nvSpPr>
+          <p:cNvPr id="4" name="TextBox 3"/>
+          <p:cNvSpPr txBox="1"/>
+          <p:nvPr/>
+        </p:nvSpPr>
+        <p:spPr>
+          <a:xfrm>
+            <a:off x="640080" y="621792"/>
+            <a:ext cx="10241280" cy="914400"/>
+          </a:xfrm>
+          <a:prstGeom prst="rect">
+            <a:avLst/>
+          </a:prstGeom>
+          <a:noFill/>
+        </p:spPr>
+        <p:txBody>
+          <a:bodyPr wrap="square" anchor="t" lIns="45720" rIns="45720">
+            <a:spAutoFit/>
+          </a:bodyPr>
+          <a:lstStyle/>
+          <a:p>
+            <a:pPr algn="l">
+              <a:spcAft>
+                <a:spcPts val="1440"/>
+              </a:spcAft>
+            </a:pPr>
+            <a:r>
+              <a:rPr sz="3200" b="1">
+                <a:solidFill>
+                  <a:srgbClr val="0B0B0B"/>
+                </a:solidFill>
+                <a:latin typeface="Calibri"/>
+              </a:rPr>
+              <a:t>The core is linguistically real</a:t>
+            </a:r>
+          </a:p>
+        </p:txBody>
+      </p:sp>
+      <p:cxnSp>
+        <p:nvCxnSpPr>
+          <p:cNvPr id="5" name="Connector 4"/>
+          <p:cNvCxnSpPr/>
+          <p:nvPr/>
+        </p:nvCxnSpPr>
+        <p:spPr>
+          <a:xfrm>
+            <a:off x="640080" y="6446520"/>
+            <a:ext cx="10911535" cy="0"/>
+          </a:xfrm>
+          <a:prstGeom prst="line">
+            <a:avLst/>
+          </a:prstGeom>
+          <a:ln w="9525">
+            <a:solidFill>
+              <a:srgbClr val="E6E5E1"/>
+            </a:solidFill>
+          </a:ln>
+        </p:spPr>
+        <p:style>
+          <a:lnRef idx="2">
+            <a:schemeClr val="accent1"/>
+          </a:lnRef>
+          <a:fillRef idx="0">
+            <a:schemeClr val="accent1"/>
+          </a:fillRef>
+          <a:effectRef idx="1">
+            <a:schemeClr val="accent1"/>
+          </a:effectRef>
+          <a:fontRef idx="minor">
+            <a:schemeClr val="tx1"/>
+          </a:fontRef>
+        </p:style>
+      </p:cxnSp>
+      <p:sp>
+        <p:nvSpPr>
+          <p:cNvPr id="6" name="TextBox 5"/>
+          <p:cNvSpPr txBox="1"/>
+          <p:nvPr/>
+        </p:nvSpPr>
+        <p:spPr>
+          <a:xfrm>
+            <a:off x="640080" y="6473952"/>
+            <a:ext cx="8229600" cy="320040"/>
+          </a:xfrm>
+          <a:prstGeom prst="rect">
+            <a:avLst/>
+          </a:prstGeom>
+          <a:noFill/>
+        </p:spPr>
+        <p:txBody>
+          <a:bodyPr wrap="square" anchor="t" lIns="45720" rIns="45720">
+            <a:spAutoFit/>
+          </a:bodyPr>
+          <a:lstStyle/>
+          <a:p>
+            <a:pPr algn="l">
+              <a:spcAft>
+                <a:spcPts val="495"/>
+              </a:spcAft>
+            </a:pPr>
+            <a:r>
+              <a:rPr sz="1100" b="0">
+                <a:solidFill>
+                  <a:srgbClr val="8A8984"/>
+                </a:solidFill>
+                <a:latin typeface="Calibri"/>
+              </a:rPr>
+              <a:t>Belciug &amp; Pelican · The Hidden Core of Romanian · ConsILR 2026</a:t>
+            </a:r>
+          </a:p>
+        </p:txBody>
+      </p:sp>
+      <p:pic>
+        <p:nvPicPr>
+          <p:cNvPr id="7" name="Picture 6" descr="fig2_enrichment.png"/>
+          <p:cNvPicPr>
+            <a:picLocks noChangeAspect="1"/>
+          </p:cNvPicPr>
+          <p:nvPr/>
+        </p:nvPicPr>
+        <p:blipFill>
+          <a:blip r:embed="rId3"/>
+          <a:stretch>
+            <a:fillRect/>
+          </a:stretch>
+        </p:blipFill>
+        <p:spPr>
+          <a:xfrm>
+            <a:off x="548640" y="1691640"/>
+            <a:ext cx="7589520" cy="3095167"/>
+          </a:xfrm>
+          <a:prstGeom prst="rect">
+            <a:avLst/>
+          </a:prstGeom>
+        </p:spPr>
+      </p:pic>
+      <p:sp>
+        <p:nvSpPr>
+          <p:cNvPr id="8" name="TextBox 7"/>
+          <p:cNvSpPr txBox="1"/>
+          <p:nvPr/>
+        </p:nvSpPr>
+        <p:spPr>
+          <a:xfrm>
+            <a:off x="8412480" y="1828800"/>
+            <a:ext cx="3474720" cy="4023360"/>
+          </a:xfrm>
+          <a:prstGeom prst="rect">
+            <a:avLst/>
+          </a:prstGeom>
+          <a:noFill/>
+        </p:spPr>
+        <p:txBody>
+          <a:bodyPr wrap="square" anchor="t" lIns="45720" rIns="45720">
+            <a:spAutoFit/>
+          </a:bodyPr>
+          <a:lstStyle/>
+          <a:p>
+            <a:pPr algn="l">
+              <a:spcAft>
+                <a:spcPts val="810"/>
+              </a:spcAft>
+            </a:pPr>
+            <a:r>
+              <a:rPr sz="3000" b="1" i="0">
+                <a:solidFill>
+                  <a:srgbClr val="2A78D6"/>
+                </a:solidFill>
+                <a:latin typeface="Calibri"/>
+              </a:rPr>
+              <a:t>98%</a:t>
+            </a:r>
+            <a:r>
+              <a:rPr sz="1800" b="0">
+                <a:solidFill>
+                  <a:srgbClr val="0B0B0B"/>
+                </a:solidFill>
+                <a:latin typeface="Calibri"/>
+              </a:rPr>
+              <a:t> of the Swadesh list (about 200 basic meanings used in comparative linguistics) in the Kernel</a:t>
+            </a:r>
+          </a:p>
+          <a:p>
+            <a:pPr algn="l">
+              <a:spcAft>
+                <a:spcPts val="810"/>
+              </a:spcAft>
+            </a:pPr>
+            <a:r>
+              <a:rPr sz="3000" b="1" i="0">
+                <a:solidFill>
+                  <a:srgbClr val="2A78D6"/>
+                </a:solidFill>
+                <a:latin typeface="Calibri"/>
+              </a:rPr>
+              <a:t>95%</a:t>
+            </a:r>
+            <a:r>
+              <a:rPr sz="1800" b="0">
+                <a:solidFill>
+                  <a:srgbClr val="0B0B0B"/>
+                </a:solidFill>
+                <a:latin typeface="Calibri"/>
+              </a:rPr>
+              <a:t> of Graur’s words in the Kernel</a:t>
+            </a:r>
+          </a:p>
+          <a:p>
+            <a:pPr algn="l">
+              <a:spcAft>
+                <a:spcPts val="810"/>
+              </a:spcAft>
+            </a:pPr>
+            <a:r>
+              <a:rPr sz="1800" b="0" i="0">
+                <a:solidFill>
+                  <a:srgbClr val="52514E"/>
+                </a:solidFill>
+                <a:latin typeface="Calibri"/>
+              </a:rPr>
+              <a:t>chance: 33%</a:t>
+            </a:r>
+          </a:p>
+          <a:p>
+            <a:pPr algn="l">
+              <a:spcAft>
+                <a:spcPts val="810"/>
+              </a:spcAft>
+            </a:pPr>
+            <a:r>
+              <a:rPr sz="1800" b="0">
+                <a:solidFill>
+                  <a:srgbClr val="0B0B0B"/>
+                </a:solidFill>
+                <a:latin typeface="Calibri"/>
+              </a:rPr>
+              <a:t>Graur’s most certain words are the most central: 97% in the Kernel, 49% in the MinSet (wider groups: 25%, 32%).</a:t>
+            </a:r>
+          </a:p>
+        </p:txBody>
+      </p:sp>
+    </p:spTree>
+  </p:cSld>
+  <p:clrMapOvr>
+    <a:masterClrMapping/>
+  </p:clrMapOvr>
+</p:sld>
+</file>
+
+<file path=ppt/slides/slide11.xml><?xml version="1.0" encoding="utf-8"?>
 <p:sld xmlns:a="http://schemas.openxmlformats.org/drawingml/2006/main" xmlns:p="http://schemas.openxmlformats.org/presentationml/2006/main" xmlns:r="http://schemas.openxmlformats.org/officeDocument/2006/relationships">
   <p:cSld>
     <p:bg>
@@ -6100,355 +6502,6 @@
 </p:sld>
 </file>
 
-<file path=ppt/slides/slide11.xml><?xml version="1.0" encoding="utf-8"?>
-<p:sld xmlns:a="http://schemas.openxmlformats.org/drawingml/2006/main" xmlns:p="http://schemas.openxmlformats.org/presentationml/2006/main" xmlns:r="http://schemas.openxmlformats.org/officeDocument/2006/relationships">
-  <p:cSld>
-    <p:bg>
-      <p:bgPr>
-        <a:solidFill>
-          <a:srgbClr val="FCFCFB"/>
-        </a:solidFill>
-        <a:effectLst/>
-      </p:bgPr>
-    </p:bg>
-    <p:spTree>
-      <p:nvGrpSpPr>
-        <p:cNvPr id="1" name=""/>
-        <p:cNvGrpSpPr/>
-        <p:nvPr/>
-      </p:nvGrpSpPr>
-      <p:grpSpPr/>
-      <p:pic>
-        <p:nvPicPr>
-          <p:cNvPr id="2" name="Picture 1" descr="logo_consilr.png"/>
-          <p:cNvPicPr>
-            <a:picLocks noChangeAspect="1"/>
-          </p:cNvPicPr>
-          <p:nvPr/>
-        </p:nvPicPr>
-        <p:blipFill>
-          <a:blip r:embed="rId2"/>
-          <a:stretch>
-            <a:fillRect/>
-          </a:stretch>
-        </p:blipFill>
-        <p:spPr>
-          <a:xfrm>
-            <a:off x="10591495" y="256032"/>
-            <a:ext cx="1311965" cy="502920"/>
-          </a:xfrm>
-          <a:prstGeom prst="rect">
-            <a:avLst/>
-          </a:prstGeom>
-        </p:spPr>
-      </p:pic>
-      <p:sp>
-        <p:nvSpPr>
-          <p:cNvPr id="3" name="TextBox 2"/>
-          <p:cNvSpPr txBox="1"/>
-          <p:nvPr/>
-        </p:nvSpPr>
-        <p:spPr>
-          <a:xfrm>
-            <a:off x="640080" y="320040"/>
-            <a:ext cx="9144000" cy="365760"/>
-          </a:xfrm>
-          <a:prstGeom prst="rect">
-            <a:avLst/>
-          </a:prstGeom>
-          <a:noFill/>
-        </p:spPr>
-        <p:txBody>
-          <a:bodyPr wrap="square" anchor="t" lIns="45720" rIns="45720">
-            <a:spAutoFit/>
-          </a:bodyPr>
-          <a:lstStyle/>
-          <a:p>
-            <a:pPr algn="l">
-              <a:spcAft>
-                <a:spcPts val="585"/>
-              </a:spcAft>
-            </a:pPr>
-            <a:r>
-              <a:rPr sz="1300" b="1">
-                <a:solidFill>
-                  <a:srgbClr val="2A78D6"/>
-                </a:solidFill>
-                <a:latin typeface="Calibri"/>
-              </a:rPr>
-              <a:t>RESULT 4</a:t>
-            </a:r>
-          </a:p>
-        </p:txBody>
-      </p:sp>
-      <p:sp>
-        <p:nvSpPr>
-          <p:cNvPr id="4" name="TextBox 3"/>
-          <p:cNvSpPr txBox="1"/>
-          <p:nvPr/>
-        </p:nvSpPr>
-        <p:spPr>
-          <a:xfrm>
-            <a:off x="640080" y="621792"/>
-            <a:ext cx="10241280" cy="914400"/>
-          </a:xfrm>
-          <a:prstGeom prst="rect">
-            <a:avLst/>
-          </a:prstGeom>
-          <a:noFill/>
-        </p:spPr>
-        <p:txBody>
-          <a:bodyPr wrap="square" anchor="t" lIns="45720" rIns="45720">
-            <a:spAutoFit/>
-          </a:bodyPr>
-          <a:lstStyle/>
-          <a:p>
-            <a:pPr algn="l">
-              <a:spcAft>
-                <a:spcPts val="1440"/>
-              </a:spcAft>
-            </a:pPr>
-            <a:r>
-              <a:rPr sz="3200" b="1">
-                <a:solidFill>
-                  <a:srgbClr val="0B0B0B"/>
-                </a:solidFill>
-                <a:latin typeface="Calibri"/>
-              </a:rPr>
-              <a:t>Two cores: inherited words and working words</a:t>
-            </a:r>
-          </a:p>
-        </p:txBody>
-      </p:sp>
-      <p:cxnSp>
-        <p:nvCxnSpPr>
-          <p:cNvPr id="5" name="Connector 4"/>
-          <p:cNvCxnSpPr/>
-          <p:nvPr/>
-        </p:nvCxnSpPr>
-        <p:spPr>
-          <a:xfrm>
-            <a:off x="640080" y="6446520"/>
-            <a:ext cx="10911535" cy="0"/>
-          </a:xfrm>
-          <a:prstGeom prst="line">
-            <a:avLst/>
-          </a:prstGeom>
-          <a:ln w="9525">
-            <a:solidFill>
-              <a:srgbClr val="E6E5E1"/>
-            </a:solidFill>
-          </a:ln>
-        </p:spPr>
-        <p:style>
-          <a:lnRef idx="2">
-            <a:schemeClr val="accent1"/>
-          </a:lnRef>
-          <a:fillRef idx="0">
-            <a:schemeClr val="accent1"/>
-          </a:fillRef>
-          <a:effectRef idx="1">
-            <a:schemeClr val="accent1"/>
-          </a:effectRef>
-          <a:fontRef idx="minor">
-            <a:schemeClr val="tx1"/>
-          </a:fontRef>
-        </p:style>
-      </p:cxnSp>
-      <p:sp>
-        <p:nvSpPr>
-          <p:cNvPr id="6" name="TextBox 5"/>
-          <p:cNvSpPr txBox="1"/>
-          <p:nvPr/>
-        </p:nvSpPr>
-        <p:spPr>
-          <a:xfrm>
-            <a:off x="640080" y="6473952"/>
-            <a:ext cx="8229600" cy="320040"/>
-          </a:xfrm>
-          <a:prstGeom prst="rect">
-            <a:avLst/>
-          </a:prstGeom>
-          <a:noFill/>
-        </p:spPr>
-        <p:txBody>
-          <a:bodyPr wrap="square" anchor="t" lIns="45720" rIns="45720">
-            <a:spAutoFit/>
-          </a:bodyPr>
-          <a:lstStyle/>
-          <a:p>
-            <a:pPr algn="l">
-              <a:spcAft>
-                <a:spcPts val="495"/>
-              </a:spcAft>
-            </a:pPr>
-            <a:r>
-              <a:rPr sz="1100" b="0">
-                <a:solidFill>
-                  <a:srgbClr val="8A8984"/>
-                </a:solidFill>
-                <a:latin typeface="Calibri"/>
-              </a:rPr>
-              <a:t>Belciug &amp; Pelican · The Hidden Core of Romanian · ConsILR 2026</a:t>
-            </a:r>
-          </a:p>
-        </p:txBody>
-      </p:sp>
-      <p:pic>
-        <p:nvPicPr>
-          <p:cNvPr id="7" name="Picture 6" descr="fig4_etymology.png"/>
-          <p:cNvPicPr>
-            <a:picLocks noChangeAspect="1"/>
-          </p:cNvPicPr>
-          <p:nvPr/>
-        </p:nvPicPr>
-        <p:blipFill>
-          <a:blip r:embed="rId3"/>
-          <a:stretch>
-            <a:fillRect/>
-          </a:stretch>
-        </p:blipFill>
-        <p:spPr>
-          <a:xfrm>
-            <a:off x="548640" y="1691640"/>
-            <a:ext cx="7498079" cy="2659678"/>
-          </a:xfrm>
-          <a:prstGeom prst="rect">
-            <a:avLst/>
-          </a:prstGeom>
-        </p:spPr>
-      </p:pic>
-      <p:sp>
-        <p:nvSpPr>
-          <p:cNvPr id="8" name="TextBox 7"/>
-          <p:cNvSpPr txBox="1"/>
-          <p:nvPr/>
-        </p:nvSpPr>
-        <p:spPr>
-          <a:xfrm>
-            <a:off x="8321040" y="1783080"/>
-            <a:ext cx="3566160" cy="4206240"/>
-          </a:xfrm>
-          <a:prstGeom prst="rect">
-            <a:avLst/>
-          </a:prstGeom>
-          <a:noFill/>
-        </p:spPr>
-        <p:txBody>
-          <a:bodyPr wrap="square" anchor="t" lIns="45720" rIns="45720">
-            <a:spAutoFit/>
-          </a:bodyPr>
-          <a:lstStyle/>
-          <a:p>
-            <a:pPr algn="l">
-              <a:spcAft>
-                <a:spcPts val="765"/>
-              </a:spcAft>
-            </a:pPr>
-            <a:r>
-              <a:rPr sz="1700" b="1" i="0">
-                <a:solidFill>
-                  <a:srgbClr val="0B0B0B"/>
-                </a:solidFill>
-                <a:latin typeface="Calibri"/>
-              </a:rPr>
-              <a:t>Graur’s core: </a:t>
-            </a:r>
-            <a:r>
-              <a:rPr sz="1700" b="0">
-                <a:solidFill>
-                  <a:srgbClr val="0B0B0B"/>
-                </a:solidFill>
-                <a:latin typeface="Calibri"/>
-              </a:rPr>
-              <a:t>stable, inherited (Latin + Slavic).</a:t>
-            </a:r>
-          </a:p>
-          <a:p>
-            <a:pPr algn="l">
-              <a:spcAft>
-                <a:spcPts val="765"/>
-              </a:spcAft>
-            </a:pPr>
-            <a:r>
-              <a:rPr sz="1700" b="1" i="0">
-                <a:solidFill>
-                  <a:srgbClr val="0B0B0B"/>
-                </a:solidFill>
-                <a:latin typeface="Calibri"/>
-              </a:rPr>
-              <a:t>The DEX’s working core: </a:t>
-            </a:r>
-            <a:r>
-              <a:rPr sz="1700" b="0">
-                <a:solidFill>
-                  <a:srgbClr val="0B0B0B"/>
-                </a:solidFill>
-                <a:latin typeface="Calibri"/>
-              </a:rPr>
-              <a:t>learned words: acțiune, rezultat, persoană, substanță…</a:t>
-            </a:r>
-          </a:p>
-          <a:p>
-            <a:pPr algn="l">
-              <a:spcAft>
-                <a:spcPts val="765"/>
-              </a:spcAft>
-            </a:pPr>
-            <a:r>
-              <a:rPr sz="1700" b="0">
-                <a:solidFill>
-                  <a:srgbClr val="0B0B0B"/>
-                </a:solidFill>
-                <a:latin typeface="Calibri"/>
-              </a:rPr>
-              <a:t>Only 437 of Graur’s words are among the 1,419 most-used defining words.</a:t>
-            </a:r>
-          </a:p>
-          <a:p>
-            <a:pPr algn="l">
-              <a:spcAft>
-                <a:spcPts val="765"/>
-              </a:spcAft>
-            </a:pPr>
-            <a:r>
-              <a:rPr sz="1700" b="1" i="0">
-                <a:solidFill>
-                  <a:srgbClr val="0B0B0B"/>
-                </a:solidFill>
-                <a:latin typeface="Calibri"/>
-              </a:rPr>
-              <a:t>Outside the Kernel: </a:t>
-            </a:r>
-            <a:r>
-              <a:rPr sz="1700" b="0" i="1">
-                <a:solidFill>
-                  <a:srgbClr val="0B0B0B"/>
-                </a:solidFill>
-                <a:latin typeface="Calibri"/>
-              </a:rPr>
-              <a:t>arici, mânz, țap, țarc, teasc, topor, prag…</a:t>
-            </a:r>
-            <a:r>
-              <a:rPr sz="1700" b="0">
-                <a:solidFill>
-                  <a:srgbClr val="0B0B0B"/>
-                </a:solidFill>
-                <a:latin typeface="Calibri"/>
-              </a:rPr>
-              <a:t> (rural words that define nothing else)</a:t>
-            </a:r>
-          </a:p>
-        </p:txBody>
-      </p:sp>
-    </p:spTree>
-  </p:cSld>
-  <p:clrMapOvr>
-    <a:masterClrMapping/>
-  </p:clrMapOvr>
-</p:sld>
-</file>
-
 <file path=ppt/slides/slide12.xml><?xml version="1.0" encoding="utf-8"?>
 <p:sld xmlns:a="http://schemas.openxmlformats.org/drawingml/2006/main" xmlns:p="http://schemas.openxmlformats.org/presentationml/2006/main" xmlns:r="http://schemas.openxmlformats.org/officeDocument/2006/relationships">
   <p:cSld>
@@ -6525,7 +6578,7 @@
                 </a:solidFill>
                 <a:latin typeface="Calibri"/>
               </a:rPr>
-              <a:t>DISCUSSION</a:t>
+              <a:t>RESULT 4</a:t>
             </a:r>
           </a:p>
         </p:txBody>
@@ -6564,7 +6617,7 @@
                 </a:solidFill>
                 <a:latin typeface="Calibri"/>
               </a:rPr>
-              <a:t>Implications for Romanian lexicography and linguistics</a:t>
+              <a:t>Two cores: inherited words and working words</a:t>
             </a:r>
           </a:p>
         </p:txBody>
@@ -6643,50 +6696,30 @@
           </a:p>
         </p:txBody>
       </p:sp>
-      <p:sp>
-        <p:nvSpPr>
-          <p:cNvPr id="7" name="Rounded Rectangle 6"/>
-          <p:cNvSpPr/>
-          <p:nvPr/>
-        </p:nvSpPr>
-        <p:spPr>
-          <a:xfrm>
-            <a:off x="640080" y="1783080"/>
-            <a:ext cx="164592" cy="1051560"/>
-          </a:xfrm>
-          <a:prstGeom prst="roundRect">
-            <a:avLst/>
-          </a:prstGeom>
-          <a:solidFill>
-            <a:srgbClr val="2A78D6"/>
-          </a:solidFill>
-          <a:ln>
-            <a:noFill/>
-          </a:ln>
-          <a:effectLst/>
-        </p:spPr>
-        <p:style>
-          <a:lnRef idx="1">
-            <a:schemeClr val="accent1"/>
-          </a:lnRef>
-          <a:fillRef idx="3">
-            <a:schemeClr val="accent1"/>
-          </a:fillRef>
-          <a:effectRef idx="2">
-            <a:schemeClr val="accent1"/>
-          </a:effectRef>
-          <a:fontRef idx="minor">
-            <a:schemeClr val="lt1"/>
-          </a:fontRef>
-        </p:style>
-        <p:txBody>
-          <a:bodyPr rtlCol="0" anchor="ctr"/>
-          <a:lstStyle/>
-          <a:p>
-            <a:pPr algn="ctr"/>
-          </a:p>
-        </p:txBody>
-      </p:sp>
+      <p:pic>
+        <p:nvPicPr>
+          <p:cNvPr id="7" name="Picture 6" descr="fig4_etymology.png"/>
+          <p:cNvPicPr>
+            <a:picLocks noChangeAspect="1"/>
+          </p:cNvPicPr>
+          <p:nvPr/>
+        </p:nvPicPr>
+        <p:blipFill>
+          <a:blip r:embed="rId3"/>
+          <a:stretch>
+            <a:fillRect/>
+          </a:stretch>
+        </p:blipFill>
+        <p:spPr>
+          <a:xfrm>
+            <a:off x="548640" y="1691640"/>
+            <a:ext cx="7498079" cy="2659678"/>
+          </a:xfrm>
+          <a:prstGeom prst="rect">
+            <a:avLst/>
+          </a:prstGeom>
+        </p:spPr>
+      </p:pic>
       <p:sp>
         <p:nvSpPr>
           <p:cNvPr id="8" name="TextBox 7"/>
@@ -6695,8 +6728,8 @@
         </p:nvSpPr>
         <p:spPr>
           <a:xfrm>
-            <a:off x="1005840" y="1737360"/>
-            <a:ext cx="10424160" cy="1188720"/>
+            <a:off x="8321040" y="1783080"/>
+            <a:ext cx="3566160" cy="4206240"/>
           </a:xfrm>
           <a:prstGeom prst="rect">
             <a:avLst/>
@@ -6711,231 +6744,101 @@
           <a:p>
             <a:pPr algn="l">
               <a:spcAft>
-                <a:spcPts val="855"/>
+                <a:spcPts val="765"/>
               </a:spcAft>
             </a:pPr>
             <a:r>
-              <a:rPr sz="2400" b="1" i="0">
+              <a:rPr sz="1700" b="1" i="0">
                 <a:solidFill>
                   <a:srgbClr val="0B0B0B"/>
                 </a:solidFill>
                 <a:latin typeface="Calibri"/>
               </a:rPr>
-              <a:t>A map of circularity</a:t>
+              <a:t>Graur’s core: </a:t>
+            </a:r>
+            <a:r>
+              <a:rPr sz="1700" b="0">
+                <a:solidFill>
+                  <a:srgbClr val="0B0B0B"/>
+                </a:solidFill>
+                <a:latin typeface="Calibri"/>
+              </a:rPr>
+              <a:t>stable, inherited (Latin + Slavic).</a:t>
             </a:r>
           </a:p>
           <a:p>
             <a:pPr algn="l">
               <a:spcAft>
-                <a:spcPts val="855"/>
+                <a:spcPts val="765"/>
               </a:spcAft>
             </a:pPr>
             <a:r>
-              <a:rPr sz="1900" b="0">
+              <a:rPr sz="1700" b="1" i="0">
                 <a:solidFill>
                   <a:srgbClr val="0B0B0B"/>
                 </a:solidFill>
                 <a:latin typeface="Calibri"/>
               </a:rPr>
-              <a:t>the list of mutually defining pairs shows where the DEX relies on synonymy; useful for a revised or learner’s dictionary.</a:t>
-            </a:r>
-          </a:p>
-        </p:txBody>
-      </p:sp>
-      <p:sp>
-        <p:nvSpPr>
-          <p:cNvPr id="9" name="Rounded Rectangle 8"/>
-          <p:cNvSpPr/>
-          <p:nvPr/>
-        </p:nvSpPr>
-        <p:spPr>
-          <a:xfrm>
-            <a:off x="640080" y="3154680"/>
-            <a:ext cx="164592" cy="1051560"/>
-          </a:xfrm>
-          <a:prstGeom prst="roundRect">
-            <a:avLst/>
-          </a:prstGeom>
-          <a:solidFill>
-            <a:srgbClr val="2A78D6"/>
-          </a:solidFill>
-          <a:ln>
-            <a:noFill/>
-          </a:ln>
-          <a:effectLst/>
-        </p:spPr>
-        <p:style>
-          <a:lnRef idx="1">
-            <a:schemeClr val="accent1"/>
-          </a:lnRef>
-          <a:fillRef idx="3">
-            <a:schemeClr val="accent1"/>
-          </a:fillRef>
-          <a:effectRef idx="2">
-            <a:schemeClr val="accent1"/>
-          </a:effectRef>
-          <a:fontRef idx="minor">
-            <a:schemeClr val="lt1"/>
-          </a:fontRef>
-        </p:style>
-        <p:txBody>
-          <a:bodyPr rtlCol="0" anchor="ctr"/>
-          <a:lstStyle/>
-          <a:p>
-            <a:pPr algn="ctr"/>
-          </a:p>
-        </p:txBody>
-      </p:sp>
-      <p:sp>
-        <p:nvSpPr>
-          <p:cNvPr id="10" name="TextBox 9"/>
-          <p:cNvSpPr txBox="1"/>
-          <p:nvPr/>
-        </p:nvSpPr>
-        <p:spPr>
-          <a:xfrm>
-            <a:off x="1005840" y="3108960"/>
-            <a:ext cx="10424160" cy="1188720"/>
-          </a:xfrm>
-          <a:prstGeom prst="rect">
-            <a:avLst/>
-          </a:prstGeom>
-          <a:noFill/>
-        </p:spPr>
-        <p:txBody>
-          <a:bodyPr wrap="square" anchor="t" lIns="45720" rIns="45720">
-            <a:spAutoFit/>
-          </a:bodyPr>
-          <a:lstStyle/>
+              <a:t>The DEX’s working core: </a:t>
+            </a:r>
+            <a:r>
+              <a:rPr sz="1700" b="0">
+                <a:solidFill>
+                  <a:srgbClr val="0B0B0B"/>
+                </a:solidFill>
+                <a:latin typeface="Calibri"/>
+              </a:rPr>
+              <a:t>learned words: acțiune, rezultat, persoană, substanță…</a:t>
+            </a:r>
+          </a:p>
           <a:p>
             <a:pPr algn="l">
               <a:spcAft>
-                <a:spcPts val="855"/>
+                <a:spcPts val="765"/>
               </a:spcAft>
             </a:pPr>
             <a:r>
-              <a:rPr sz="2400" b="1" i="0">
+              <a:rPr sz="1700" b="0">
                 <a:solidFill>
                   <a:srgbClr val="0B0B0B"/>
                 </a:solidFill>
                 <a:latin typeface="Calibri"/>
               </a:rPr>
-              <a:t>A test of a classical idea</a:t>
+              <a:t>Only 437 of Graur’s words are among the 1,419 most-used defining words.</a:t>
             </a:r>
           </a:p>
           <a:p>
             <a:pPr algn="l">
               <a:spcAft>
-                <a:spcPts val="855"/>
+                <a:spcPts val="765"/>
               </a:spcAft>
             </a:pPr>
             <a:r>
-              <a:rPr sz="1900" b="0">
+              <a:rPr sz="1700" b="1" i="0">
                 <a:solidFill>
                   <a:srgbClr val="0B0B0B"/>
                 </a:solidFill>
                 <a:latin typeface="Calibri"/>
               </a:rPr>
-              <a:t>Graur’s intuition is confirmed with data he never had, and placed in context.</a:t>
-            </a:r>
-          </a:p>
-        </p:txBody>
-      </p:sp>
-      <p:sp>
-        <p:nvSpPr>
-          <p:cNvPr id="11" name="Rounded Rectangle 10"/>
-          <p:cNvSpPr/>
-          <p:nvPr/>
-        </p:nvSpPr>
-        <p:spPr>
-          <a:xfrm>
-            <a:off x="640080" y="4526280"/>
-            <a:ext cx="164592" cy="1051560"/>
-          </a:xfrm>
-          <a:prstGeom prst="roundRect">
-            <a:avLst/>
-          </a:prstGeom>
-          <a:solidFill>
-            <a:srgbClr val="2A78D6"/>
-          </a:solidFill>
-          <a:ln>
-            <a:noFill/>
-          </a:ln>
-          <a:effectLst/>
-        </p:spPr>
-        <p:style>
-          <a:lnRef idx="1">
-            <a:schemeClr val="accent1"/>
-          </a:lnRef>
-          <a:fillRef idx="3">
-            <a:schemeClr val="accent1"/>
-          </a:fillRef>
-          <a:effectRef idx="2">
-            <a:schemeClr val="accent1"/>
-          </a:effectRef>
-          <a:fontRef idx="minor">
-            <a:schemeClr val="lt1"/>
-          </a:fontRef>
-        </p:style>
-        <p:txBody>
-          <a:bodyPr rtlCol="0" anchor="ctr"/>
-          <a:lstStyle/>
-          <a:p>
-            <a:pPr algn="ctr"/>
-          </a:p>
-        </p:txBody>
-      </p:sp>
-      <p:sp>
-        <p:nvSpPr>
-          <p:cNvPr id="12" name="TextBox 11"/>
-          <p:cNvSpPr txBox="1"/>
-          <p:nvPr/>
-        </p:nvSpPr>
-        <p:spPr>
-          <a:xfrm>
-            <a:off x="1005840" y="4480560"/>
-            <a:ext cx="10424160" cy="1188720"/>
-          </a:xfrm>
-          <a:prstGeom prst="rect">
-            <a:avLst/>
-          </a:prstGeom>
-          <a:noFill/>
-        </p:spPr>
-        <p:txBody>
-          <a:bodyPr wrap="square" anchor="t" lIns="45720" rIns="45720">
-            <a:spAutoFit/>
-          </a:bodyPr>
-          <a:lstStyle/>
-          <a:p>
-            <a:pPr algn="l">
-              <a:spcAft>
-                <a:spcPts val="855"/>
-              </a:spcAft>
-            </a:pPr>
-            <a:r>
-              <a:rPr sz="2400" b="1" i="0">
+              <a:t>Outside the Kernel: </a:t>
+            </a:r>
+            <a:r>
+              <a:rPr sz="1700" b="0" i="1">
                 <a:solidFill>
                   <a:srgbClr val="0B0B0B"/>
                 </a:solidFill>
                 <a:latin typeface="Calibri"/>
               </a:rPr>
-              <a:t>AI as an instrument</a:t>
-            </a:r>
-          </a:p>
-          <a:p>
-            <a:pPr algn="l">
-              <a:spcAft>
-                <a:spcPts val="855"/>
-              </a:spcAft>
-            </a:pPr>
-            <a:r>
-              <a:rPr sz="1900" b="0">
+              <a:t>arici, mânz, țap, țarc, teasc, topor, prag…</a:t>
+            </a:r>
+            <a:r>
+              <a:rPr sz="1700" b="0">
                 <a:solidFill>
                   <a:srgbClr val="0B0B0B"/>
                 </a:solidFill>
                 <a:latin typeface="Calibri"/>
               </a:rPr>
-              <a:t>a narrow, checkable task at full scale; reliability measured; conclusions tested without the model.</a:t>
+              <a:t> (rural words that define nothing else)</a:t>
             </a:r>
           </a:p>
         </p:txBody>
@@ -7024,7 +6927,7 @@
                 </a:solidFill>
                 <a:latin typeface="Calibri"/>
               </a:rPr>
-              <a:t>HOW CONFIDENT ARE WE?</a:t>
+              <a:t>DISCUSSION</a:t>
             </a:r>
           </a:p>
         </p:txBody>
@@ -7063,7 +6966,7 @@
                 </a:solidFill>
                 <a:latin typeface="Calibri"/>
               </a:rPr>
-              <a:t>Strength of the evidence</a:t>
+              <a:t>Implications for Romanian lexicography and linguistics</a:t>
             </a:r>
           </a:p>
         </p:txBody>
@@ -7150,8 +7053,8 @@
         </p:nvSpPr>
         <p:spPr>
           <a:xfrm>
-            <a:off x="640080" y="1737360"/>
-            <a:ext cx="1645920" cy="548640"/>
+            <a:off x="640080" y="1783080"/>
+            <a:ext cx="164592" cy="1051560"/>
           </a:xfrm>
           <a:prstGeom prst="roundRect">
             <a:avLst/>
@@ -7183,15 +7086,6 @@
           <a:lstStyle/>
           <a:p>
             <a:pPr algn="ctr"/>
-            <a:r>
-              <a:rPr sz="1600" b="1">
-                <a:solidFill>
-                  <a:srgbClr val="FCFCFB"/>
-                </a:solidFill>
-                <a:latin typeface="Calibri"/>
-              </a:rPr>
-              <a:t>Strong</a:t>
-            </a:r>
           </a:p>
         </p:txBody>
       </p:sp>
@@ -7203,8 +7097,8 @@
         </p:nvSpPr>
         <p:spPr>
           <a:xfrm>
-            <a:off x="2514600" y="1783080"/>
-            <a:ext cx="9326880" cy="548640"/>
+            <a:off x="1005840" y="1737360"/>
+            <a:ext cx="10424160" cy="1188720"/>
           </a:xfrm>
           <a:prstGeom prst="rect">
             <a:avLst/>
@@ -7219,17 +7113,33 @@
           <a:p>
             <a:pPr algn="l">
               <a:spcAft>
-                <a:spcPts val="810"/>
+                <a:spcPts val="855"/>
               </a:spcAft>
             </a:pPr>
             <a:r>
-              <a:rPr sz="1800" b="0">
+              <a:rPr sz="2400" b="1" i="0">
                 <a:solidFill>
                   <a:srgbClr val="0B0B0B"/>
                 </a:solidFill>
                 <a:latin typeface="Calibri"/>
               </a:rPr>
-              <a:t>The DEX is much more circular than English dictionaries; the cause is reciprocal (synonym) definition.</a:t>
+              <a:t>A map of circularity</a:t>
+            </a:r>
+          </a:p>
+          <a:p>
+            <a:pPr algn="l">
+              <a:spcAft>
+                <a:spcPts val="855"/>
+              </a:spcAft>
+            </a:pPr>
+            <a:r>
+              <a:rPr sz="1900" b="0">
+                <a:solidFill>
+                  <a:srgbClr val="0B0B0B"/>
+                </a:solidFill>
+                <a:latin typeface="Calibri"/>
+              </a:rPr>
+              <a:t>the list of mutually defining pairs shows where the DEX relies on synonymy; useful for a revised or learner’s dictionary.</a:t>
             </a:r>
           </a:p>
         </p:txBody>
@@ -7242,8 +7152,8 @@
         </p:nvSpPr>
         <p:spPr>
           <a:xfrm>
-            <a:off x="640080" y="2450591"/>
-            <a:ext cx="1645920" cy="548640"/>
+            <a:off x="640080" y="3154680"/>
+            <a:ext cx="164592" cy="1051560"/>
           </a:xfrm>
           <a:prstGeom prst="roundRect">
             <a:avLst/>
@@ -7275,15 +7185,6 @@
           <a:lstStyle/>
           <a:p>
             <a:pPr algn="ctr"/>
-            <a:r>
-              <a:rPr sz="1600" b="1">
-                <a:solidFill>
-                  <a:srgbClr val="FCFCFB"/>
-                </a:solidFill>
-                <a:latin typeface="Calibri"/>
-              </a:rPr>
-              <a:t>Strong</a:t>
-            </a:r>
           </a:p>
         </p:txBody>
       </p:sp>
@@ -7295,8 +7196,8 @@
         </p:nvSpPr>
         <p:spPr>
           <a:xfrm>
-            <a:off x="2514600" y="2496311"/>
-            <a:ext cx="9326880" cy="548640"/>
+            <a:off x="1005840" y="3108960"/>
+            <a:ext cx="10424160" cy="1188720"/>
           </a:xfrm>
           <a:prstGeom prst="rect">
             <a:avLst/>
@@ -7311,17 +7212,33 @@
           <a:p>
             <a:pPr algn="l">
               <a:spcAft>
-                <a:spcPts val="810"/>
+                <a:spcPts val="855"/>
               </a:spcAft>
             </a:pPr>
             <a:r>
-              <a:rPr sz="1800" b="0">
+              <a:rPr sz="2400" b="1" i="0">
                 <a:solidFill>
                   <a:srgbClr val="0B0B0B"/>
                 </a:solidFill>
                 <a:latin typeface="Calibri"/>
               </a:rPr>
-              <a:t>Swadesh and Graur words are concentrated in the Kernel (p &lt; 10⁻²⁰⁰).</a:t>
+              <a:t>A test of a classical idea</a:t>
+            </a:r>
+          </a:p>
+          <a:p>
+            <a:pPr algn="l">
+              <a:spcAft>
+                <a:spcPts val="855"/>
+              </a:spcAft>
+            </a:pPr>
+            <a:r>
+              <a:rPr sz="1900" b="0">
+                <a:solidFill>
+                  <a:srgbClr val="0B0B0B"/>
+                </a:solidFill>
+                <a:latin typeface="Calibri"/>
+              </a:rPr>
+              <a:t>Graur’s intuition is confirmed with data he never had, and placed in context.</a:t>
             </a:r>
           </a:p>
         </p:txBody>
@@ -7334,14 +7251,14 @@
         </p:nvSpPr>
         <p:spPr>
           <a:xfrm>
-            <a:off x="640080" y="3163824"/>
-            <a:ext cx="1645920" cy="548640"/>
+            <a:off x="640080" y="4526280"/>
+            <a:ext cx="164592" cy="1051560"/>
           </a:xfrm>
           <a:prstGeom prst="roundRect">
             <a:avLst/>
           </a:prstGeom>
           <a:solidFill>
-            <a:srgbClr val="1BAF7A"/>
+            <a:srgbClr val="2A78D6"/>
           </a:solidFill>
           <a:ln>
             <a:noFill/>
@@ -7367,15 +7284,6 @@
           <a:lstStyle/>
           <a:p>
             <a:pPr algn="ctr"/>
-            <a:r>
-              <a:rPr sz="1600" b="1">
-                <a:solidFill>
-                  <a:srgbClr val="FCFCFB"/>
-                </a:solidFill>
-                <a:latin typeface="Calibri"/>
-              </a:rPr>
-              <a:t>Good</a:t>
-            </a:r>
           </a:p>
         </p:txBody>
       </p:sp>
@@ -7387,8 +7295,8 @@
         </p:nvSpPr>
         <p:spPr>
           <a:xfrm>
-            <a:off x="2514600" y="3209544"/>
-            <a:ext cx="9326880" cy="548640"/>
+            <a:off x="1005840" y="4480560"/>
+            <a:ext cx="10424160" cy="1188720"/>
           </a:xfrm>
           <a:prstGeom prst="rect">
             <a:avLst/>
@@ -7403,293 +7311,33 @@
           <a:p>
             <a:pPr algn="l">
               <a:spcAft>
-                <a:spcPts val="810"/>
+                <a:spcPts val="855"/>
               </a:spcAft>
             </a:pPr>
             <a:r>
-              <a:rPr sz="1800" b="0">
+              <a:rPr sz="2400" b="1" i="0">
                 <a:solidFill>
                   <a:srgbClr val="0B0B0B"/>
                 </a:solidFill>
                 <a:latin typeface="Calibri"/>
               </a:rPr>
-              <a:t>MinSet size: proven bounds 6,193–6,325, a gap of 2.1%; not computed exactly.</a:t>
-            </a:r>
-          </a:p>
-        </p:txBody>
-      </p:sp>
-      <p:sp>
-        <p:nvSpPr>
-          <p:cNvPr id="13" name="Rounded Rectangle 12"/>
-          <p:cNvSpPr/>
-          <p:nvPr/>
-        </p:nvSpPr>
-        <p:spPr>
-          <a:xfrm>
-            <a:off x="640080" y="3877056"/>
-            <a:ext cx="1645920" cy="548640"/>
-          </a:xfrm>
-          <a:prstGeom prst="roundRect">
-            <a:avLst/>
-          </a:prstGeom>
-          <a:solidFill>
-            <a:srgbClr val="1BAF7A"/>
-          </a:solidFill>
-          <a:ln>
-            <a:noFill/>
-          </a:ln>
-          <a:effectLst/>
-        </p:spPr>
-        <p:style>
-          <a:lnRef idx="1">
-            <a:schemeClr val="accent1"/>
-          </a:lnRef>
-          <a:fillRef idx="3">
-            <a:schemeClr val="accent1"/>
-          </a:fillRef>
-          <a:effectRef idx="2">
-            <a:schemeClr val="accent1"/>
-          </a:effectRef>
-          <a:fontRef idx="minor">
-            <a:schemeClr val="lt1"/>
-          </a:fontRef>
-        </p:style>
-        <p:txBody>
-          <a:bodyPr rtlCol="0" anchor="ctr"/>
-          <a:lstStyle/>
-          <a:p>
-            <a:pPr algn="ctr"/>
-            <a:r>
-              <a:rPr sz="1600" b="1">
-                <a:solidFill>
-                  <a:srgbClr val="FCFCFB"/>
-                </a:solidFill>
-                <a:latin typeface="Calibri"/>
-              </a:rPr>
-              <a:t>Good</a:t>
-            </a:r>
-          </a:p>
-        </p:txBody>
-      </p:sp>
-      <p:sp>
-        <p:nvSpPr>
-          <p:cNvPr id="14" name="TextBox 13"/>
-          <p:cNvSpPr txBox="1"/>
-          <p:nvPr/>
-        </p:nvSpPr>
-        <p:spPr>
-          <a:xfrm>
-            <a:off x="2514600" y="3922776"/>
-            <a:ext cx="9326880" cy="548640"/>
-          </a:xfrm>
-          <a:prstGeom prst="rect">
-            <a:avLst/>
-          </a:prstGeom>
-          <a:noFill/>
-        </p:spPr>
-        <p:txBody>
-          <a:bodyPr wrap="square" anchor="t" lIns="45720" rIns="45720">
-            <a:spAutoFit/>
-          </a:bodyPr>
-          <a:lstStyle/>
+              <a:t>AI as an instrument</a:t>
+            </a:r>
+          </a:p>
           <a:p>
             <a:pPr algn="l">
               <a:spcAft>
-                <a:spcPts val="810"/>
+                <a:spcPts val="855"/>
               </a:spcAft>
             </a:pPr>
             <a:r>
-              <a:rPr sz="1800" b="0">
+              <a:rPr sz="1900" b="0">
                 <a:solidFill>
                   <a:srgbClr val="0B0B0B"/>
                 </a:solidFill>
                 <a:latin typeface="Calibri"/>
               </a:rPr>
-              <a:t>Graur’s most certain words are the most central; two marks out of 1,419 uncertain in our transcription.</a:t>
-            </a:r>
-          </a:p>
-        </p:txBody>
-      </p:sp>
-      <p:sp>
-        <p:nvSpPr>
-          <p:cNvPr id="15" name="Rounded Rectangle 14"/>
-          <p:cNvSpPr/>
-          <p:nvPr/>
-        </p:nvSpPr>
-        <p:spPr>
-          <a:xfrm>
-            <a:off x="640080" y="4590288"/>
-            <a:ext cx="1645920" cy="548640"/>
-          </a:xfrm>
-          <a:prstGeom prst="roundRect">
-            <a:avLst/>
-          </a:prstGeom>
-          <a:solidFill>
-            <a:srgbClr val="EB6834"/>
-          </a:solidFill>
-          <a:ln>
-            <a:noFill/>
-          </a:ln>
-          <a:effectLst/>
-        </p:spPr>
-        <p:style>
-          <a:lnRef idx="1">
-            <a:schemeClr val="accent1"/>
-          </a:lnRef>
-          <a:fillRef idx="3">
-            <a:schemeClr val="accent1"/>
-          </a:fillRef>
-          <a:effectRef idx="2">
-            <a:schemeClr val="accent1"/>
-          </a:effectRef>
-          <a:fontRef idx="minor">
-            <a:schemeClr val="lt1"/>
-          </a:fontRef>
-        </p:style>
-        <p:txBody>
-          <a:bodyPr rtlCol="0" anchor="ctr"/>
-          <a:lstStyle/>
-          <a:p>
-            <a:pPr algn="ctr"/>
-            <a:r>
-              <a:rPr sz="1600" b="1">
-                <a:solidFill>
-                  <a:srgbClr val="FCFCFB"/>
-                </a:solidFill>
-                <a:latin typeface="Calibri"/>
-              </a:rPr>
-              <a:t>Indicative</a:t>
-            </a:r>
-          </a:p>
-        </p:txBody>
-      </p:sp>
-      <p:sp>
-        <p:nvSpPr>
-          <p:cNvPr id="16" name="TextBox 15"/>
-          <p:cNvSpPr txBox="1"/>
-          <p:nvPr/>
-        </p:nvSpPr>
-        <p:spPr>
-          <a:xfrm>
-            <a:off x="2514600" y="4636008"/>
-            <a:ext cx="9326880" cy="548640"/>
-          </a:xfrm>
-          <a:prstGeom prst="rect">
-            <a:avLst/>
-          </a:prstGeom>
-          <a:noFill/>
-        </p:spPr>
-        <p:txBody>
-          <a:bodyPr wrap="square" anchor="t" lIns="45720" rIns="45720">
-            <a:spAutoFit/>
-          </a:bodyPr>
-          <a:lstStyle/>
-          <a:p>
-            <a:pPr algn="l">
-              <a:spcAft>
-                <a:spcPts val="810"/>
-              </a:spcAft>
-            </a:pPr>
-            <a:r>
-              <a:rPr sz="1800" b="0">
-                <a:solidFill>
-                  <a:srgbClr val="0B0B0B"/>
-                </a:solidFill>
-                <a:latin typeface="Calibri"/>
-              </a:rPr>
-              <a:t>Etymological contrast: part of the vocabulary is unclassified.</a:t>
-            </a:r>
-          </a:p>
-        </p:txBody>
-      </p:sp>
-      <p:sp>
-        <p:nvSpPr>
-          <p:cNvPr id="17" name="Rounded Rectangle 16"/>
-          <p:cNvSpPr/>
-          <p:nvPr/>
-        </p:nvSpPr>
-        <p:spPr>
-          <a:xfrm>
-            <a:off x="640080" y="5303520"/>
-            <a:ext cx="1645920" cy="548640"/>
-          </a:xfrm>
-          <a:prstGeom prst="roundRect">
-            <a:avLst/>
-          </a:prstGeom>
-          <a:solidFill>
-            <a:srgbClr val="8A8984"/>
-          </a:solidFill>
-          <a:ln>
-            <a:noFill/>
-          </a:ln>
-          <a:effectLst/>
-        </p:spPr>
-        <p:style>
-          <a:lnRef idx="1">
-            <a:schemeClr val="accent1"/>
-          </a:lnRef>
-          <a:fillRef idx="3">
-            <a:schemeClr val="accent1"/>
-          </a:fillRef>
-          <a:effectRef idx="2">
-            <a:schemeClr val="accent1"/>
-          </a:effectRef>
-          <a:fontRef idx="minor">
-            <a:schemeClr val="lt1"/>
-          </a:fontRef>
-        </p:style>
-        <p:txBody>
-          <a:bodyPr rtlCol="0" anchor="ctr"/>
-          <a:lstStyle/>
-          <a:p>
-            <a:pPr algn="ctr"/>
-            <a:r>
-              <a:rPr sz="1600" b="1">
-                <a:solidFill>
-                  <a:srgbClr val="FCFCFB"/>
-                </a:solidFill>
-                <a:latin typeface="Calibri"/>
-              </a:rPr>
-              <a:t>Scope</a:t>
-            </a:r>
-          </a:p>
-        </p:txBody>
-      </p:sp>
-      <p:sp>
-        <p:nvSpPr>
-          <p:cNvPr id="18" name="TextBox 17"/>
-          <p:cNvSpPr txBox="1"/>
-          <p:nvPr/>
-        </p:nvSpPr>
-        <p:spPr>
-          <a:xfrm>
-            <a:off x="2514600" y="5349240"/>
-            <a:ext cx="9326880" cy="548640"/>
-          </a:xfrm>
-          <a:prstGeom prst="rect">
-            <a:avLst/>
-          </a:prstGeom>
-          <a:noFill/>
-        </p:spPr>
-        <p:txBody>
-          <a:bodyPr wrap="square" anchor="t" lIns="45720" rIns="45720">
-            <a:spAutoFit/>
-          </a:bodyPr>
-          <a:lstStyle/>
-          <a:p>
-            <a:pPr algn="l">
-              <a:spcAft>
-                <a:spcPts val="810"/>
-              </a:spcAft>
-            </a:pPr>
-            <a:r>
-              <a:rPr sz="1800" b="0">
-                <a:solidFill>
-                  <a:srgbClr val="0B0B0B"/>
-                </a:solidFill>
-                <a:latin typeface="Calibri"/>
-              </a:rPr>
-              <a:t>One dictionary, one edition, first senses only.</a:t>
+              <a:t>a narrow, checkable task at full scale; reliability measured; conclusions tested without the model.</a:t>
             </a:r>
           </a:p>
         </p:txBody>
@@ -7778,6 +7426,760 @@
                 </a:solidFill>
                 <a:latin typeface="Calibri"/>
               </a:rPr>
+              <a:t>HOW CONFIDENT ARE WE?</a:t>
+            </a:r>
+          </a:p>
+        </p:txBody>
+      </p:sp>
+      <p:sp>
+        <p:nvSpPr>
+          <p:cNvPr id="4" name="TextBox 3"/>
+          <p:cNvSpPr txBox="1"/>
+          <p:nvPr/>
+        </p:nvSpPr>
+        <p:spPr>
+          <a:xfrm>
+            <a:off x="640080" y="621792"/>
+            <a:ext cx="10241280" cy="914400"/>
+          </a:xfrm>
+          <a:prstGeom prst="rect">
+            <a:avLst/>
+          </a:prstGeom>
+          <a:noFill/>
+        </p:spPr>
+        <p:txBody>
+          <a:bodyPr wrap="square" anchor="t" lIns="45720" rIns="45720">
+            <a:spAutoFit/>
+          </a:bodyPr>
+          <a:lstStyle/>
+          <a:p>
+            <a:pPr algn="l">
+              <a:spcAft>
+                <a:spcPts val="1440"/>
+              </a:spcAft>
+            </a:pPr>
+            <a:r>
+              <a:rPr sz="3200" b="1">
+                <a:solidFill>
+                  <a:srgbClr val="0B0B0B"/>
+                </a:solidFill>
+                <a:latin typeface="Calibri"/>
+              </a:rPr>
+              <a:t>Strength of the evidence</a:t>
+            </a:r>
+          </a:p>
+        </p:txBody>
+      </p:sp>
+      <p:cxnSp>
+        <p:nvCxnSpPr>
+          <p:cNvPr id="5" name="Connector 4"/>
+          <p:cNvCxnSpPr/>
+          <p:nvPr/>
+        </p:nvCxnSpPr>
+        <p:spPr>
+          <a:xfrm>
+            <a:off x="640080" y="6446520"/>
+            <a:ext cx="10911535" cy="0"/>
+          </a:xfrm>
+          <a:prstGeom prst="line">
+            <a:avLst/>
+          </a:prstGeom>
+          <a:ln w="9525">
+            <a:solidFill>
+              <a:srgbClr val="E6E5E1"/>
+            </a:solidFill>
+          </a:ln>
+        </p:spPr>
+        <p:style>
+          <a:lnRef idx="2">
+            <a:schemeClr val="accent1"/>
+          </a:lnRef>
+          <a:fillRef idx="0">
+            <a:schemeClr val="accent1"/>
+          </a:fillRef>
+          <a:effectRef idx="1">
+            <a:schemeClr val="accent1"/>
+          </a:effectRef>
+          <a:fontRef idx="minor">
+            <a:schemeClr val="tx1"/>
+          </a:fontRef>
+        </p:style>
+      </p:cxnSp>
+      <p:sp>
+        <p:nvSpPr>
+          <p:cNvPr id="6" name="TextBox 5"/>
+          <p:cNvSpPr txBox="1"/>
+          <p:nvPr/>
+        </p:nvSpPr>
+        <p:spPr>
+          <a:xfrm>
+            <a:off x="640080" y="6473952"/>
+            <a:ext cx="8229600" cy="320040"/>
+          </a:xfrm>
+          <a:prstGeom prst="rect">
+            <a:avLst/>
+          </a:prstGeom>
+          <a:noFill/>
+        </p:spPr>
+        <p:txBody>
+          <a:bodyPr wrap="square" anchor="t" lIns="45720" rIns="45720">
+            <a:spAutoFit/>
+          </a:bodyPr>
+          <a:lstStyle/>
+          <a:p>
+            <a:pPr algn="l">
+              <a:spcAft>
+                <a:spcPts val="495"/>
+              </a:spcAft>
+            </a:pPr>
+            <a:r>
+              <a:rPr sz="1100" b="0">
+                <a:solidFill>
+                  <a:srgbClr val="8A8984"/>
+                </a:solidFill>
+                <a:latin typeface="Calibri"/>
+              </a:rPr>
+              <a:t>Belciug &amp; Pelican · The Hidden Core of Romanian · ConsILR 2026</a:t>
+            </a:r>
+          </a:p>
+        </p:txBody>
+      </p:sp>
+      <p:sp>
+        <p:nvSpPr>
+          <p:cNvPr id="7" name="Rounded Rectangle 6"/>
+          <p:cNvSpPr/>
+          <p:nvPr/>
+        </p:nvSpPr>
+        <p:spPr>
+          <a:xfrm>
+            <a:off x="640080" y="1737360"/>
+            <a:ext cx="1645920" cy="548640"/>
+          </a:xfrm>
+          <a:prstGeom prst="roundRect">
+            <a:avLst/>
+          </a:prstGeom>
+          <a:solidFill>
+            <a:srgbClr val="2A78D6"/>
+          </a:solidFill>
+          <a:ln>
+            <a:noFill/>
+          </a:ln>
+          <a:effectLst/>
+        </p:spPr>
+        <p:style>
+          <a:lnRef idx="1">
+            <a:schemeClr val="accent1"/>
+          </a:lnRef>
+          <a:fillRef idx="3">
+            <a:schemeClr val="accent1"/>
+          </a:fillRef>
+          <a:effectRef idx="2">
+            <a:schemeClr val="accent1"/>
+          </a:effectRef>
+          <a:fontRef idx="minor">
+            <a:schemeClr val="lt1"/>
+          </a:fontRef>
+        </p:style>
+        <p:txBody>
+          <a:bodyPr rtlCol="0" anchor="ctr"/>
+          <a:lstStyle/>
+          <a:p>
+            <a:pPr algn="ctr"/>
+            <a:r>
+              <a:rPr sz="1600" b="1">
+                <a:solidFill>
+                  <a:srgbClr val="FCFCFB"/>
+                </a:solidFill>
+                <a:latin typeface="Calibri"/>
+              </a:rPr>
+              <a:t>Strong</a:t>
+            </a:r>
+          </a:p>
+        </p:txBody>
+      </p:sp>
+      <p:sp>
+        <p:nvSpPr>
+          <p:cNvPr id="8" name="TextBox 7"/>
+          <p:cNvSpPr txBox="1"/>
+          <p:nvPr/>
+        </p:nvSpPr>
+        <p:spPr>
+          <a:xfrm>
+            <a:off x="2514600" y="1783080"/>
+            <a:ext cx="9326880" cy="548640"/>
+          </a:xfrm>
+          <a:prstGeom prst="rect">
+            <a:avLst/>
+          </a:prstGeom>
+          <a:noFill/>
+        </p:spPr>
+        <p:txBody>
+          <a:bodyPr wrap="square" anchor="t" lIns="45720" rIns="45720">
+            <a:spAutoFit/>
+          </a:bodyPr>
+          <a:lstStyle/>
+          <a:p>
+            <a:pPr algn="l">
+              <a:spcAft>
+                <a:spcPts val="810"/>
+              </a:spcAft>
+            </a:pPr>
+            <a:r>
+              <a:rPr sz="1800" b="0">
+                <a:solidFill>
+                  <a:srgbClr val="0B0B0B"/>
+                </a:solidFill>
+                <a:latin typeface="Calibri"/>
+              </a:rPr>
+              <a:t>The DEX is much more circular than English dictionaries; the cause is reciprocal (synonym) definition.</a:t>
+            </a:r>
+          </a:p>
+        </p:txBody>
+      </p:sp>
+      <p:sp>
+        <p:nvSpPr>
+          <p:cNvPr id="9" name="Rounded Rectangle 8"/>
+          <p:cNvSpPr/>
+          <p:nvPr/>
+        </p:nvSpPr>
+        <p:spPr>
+          <a:xfrm>
+            <a:off x="640080" y="2450591"/>
+            <a:ext cx="1645920" cy="548640"/>
+          </a:xfrm>
+          <a:prstGeom prst="roundRect">
+            <a:avLst/>
+          </a:prstGeom>
+          <a:solidFill>
+            <a:srgbClr val="2A78D6"/>
+          </a:solidFill>
+          <a:ln>
+            <a:noFill/>
+          </a:ln>
+          <a:effectLst/>
+        </p:spPr>
+        <p:style>
+          <a:lnRef idx="1">
+            <a:schemeClr val="accent1"/>
+          </a:lnRef>
+          <a:fillRef idx="3">
+            <a:schemeClr val="accent1"/>
+          </a:fillRef>
+          <a:effectRef idx="2">
+            <a:schemeClr val="accent1"/>
+          </a:effectRef>
+          <a:fontRef idx="minor">
+            <a:schemeClr val="lt1"/>
+          </a:fontRef>
+        </p:style>
+        <p:txBody>
+          <a:bodyPr rtlCol="0" anchor="ctr"/>
+          <a:lstStyle/>
+          <a:p>
+            <a:pPr algn="ctr"/>
+            <a:r>
+              <a:rPr sz="1600" b="1">
+                <a:solidFill>
+                  <a:srgbClr val="FCFCFB"/>
+                </a:solidFill>
+                <a:latin typeface="Calibri"/>
+              </a:rPr>
+              <a:t>Strong</a:t>
+            </a:r>
+          </a:p>
+        </p:txBody>
+      </p:sp>
+      <p:sp>
+        <p:nvSpPr>
+          <p:cNvPr id="10" name="TextBox 9"/>
+          <p:cNvSpPr txBox="1"/>
+          <p:nvPr/>
+        </p:nvSpPr>
+        <p:spPr>
+          <a:xfrm>
+            <a:off x="2514600" y="2496311"/>
+            <a:ext cx="9326880" cy="548640"/>
+          </a:xfrm>
+          <a:prstGeom prst="rect">
+            <a:avLst/>
+          </a:prstGeom>
+          <a:noFill/>
+        </p:spPr>
+        <p:txBody>
+          <a:bodyPr wrap="square" anchor="t" lIns="45720" rIns="45720">
+            <a:spAutoFit/>
+          </a:bodyPr>
+          <a:lstStyle/>
+          <a:p>
+            <a:pPr algn="l">
+              <a:spcAft>
+                <a:spcPts val="810"/>
+              </a:spcAft>
+            </a:pPr>
+            <a:r>
+              <a:rPr sz="1800" b="0">
+                <a:solidFill>
+                  <a:srgbClr val="0B0B0B"/>
+                </a:solidFill>
+                <a:latin typeface="Calibri"/>
+              </a:rPr>
+              <a:t>Swadesh and Graur words are concentrated in the Kernel (p &lt; 10⁻²⁰⁰).</a:t>
+            </a:r>
+          </a:p>
+        </p:txBody>
+      </p:sp>
+      <p:sp>
+        <p:nvSpPr>
+          <p:cNvPr id="11" name="Rounded Rectangle 10"/>
+          <p:cNvSpPr/>
+          <p:nvPr/>
+        </p:nvSpPr>
+        <p:spPr>
+          <a:xfrm>
+            <a:off x="640080" y="3163824"/>
+            <a:ext cx="1645920" cy="548640"/>
+          </a:xfrm>
+          <a:prstGeom prst="roundRect">
+            <a:avLst/>
+          </a:prstGeom>
+          <a:solidFill>
+            <a:srgbClr val="1BAF7A"/>
+          </a:solidFill>
+          <a:ln>
+            <a:noFill/>
+          </a:ln>
+          <a:effectLst/>
+        </p:spPr>
+        <p:style>
+          <a:lnRef idx="1">
+            <a:schemeClr val="accent1"/>
+          </a:lnRef>
+          <a:fillRef idx="3">
+            <a:schemeClr val="accent1"/>
+          </a:fillRef>
+          <a:effectRef idx="2">
+            <a:schemeClr val="accent1"/>
+          </a:effectRef>
+          <a:fontRef idx="minor">
+            <a:schemeClr val="lt1"/>
+          </a:fontRef>
+        </p:style>
+        <p:txBody>
+          <a:bodyPr rtlCol="0" anchor="ctr"/>
+          <a:lstStyle/>
+          <a:p>
+            <a:pPr algn="ctr"/>
+            <a:r>
+              <a:rPr sz="1600" b="1">
+                <a:solidFill>
+                  <a:srgbClr val="FCFCFB"/>
+                </a:solidFill>
+                <a:latin typeface="Calibri"/>
+              </a:rPr>
+              <a:t>Good</a:t>
+            </a:r>
+          </a:p>
+        </p:txBody>
+      </p:sp>
+      <p:sp>
+        <p:nvSpPr>
+          <p:cNvPr id="12" name="TextBox 11"/>
+          <p:cNvSpPr txBox="1"/>
+          <p:nvPr/>
+        </p:nvSpPr>
+        <p:spPr>
+          <a:xfrm>
+            <a:off x="2514600" y="3209544"/>
+            <a:ext cx="9326880" cy="548640"/>
+          </a:xfrm>
+          <a:prstGeom prst="rect">
+            <a:avLst/>
+          </a:prstGeom>
+          <a:noFill/>
+        </p:spPr>
+        <p:txBody>
+          <a:bodyPr wrap="square" anchor="t" lIns="45720" rIns="45720">
+            <a:spAutoFit/>
+          </a:bodyPr>
+          <a:lstStyle/>
+          <a:p>
+            <a:pPr algn="l">
+              <a:spcAft>
+                <a:spcPts val="810"/>
+              </a:spcAft>
+            </a:pPr>
+            <a:r>
+              <a:rPr sz="1800" b="0">
+                <a:solidFill>
+                  <a:srgbClr val="0B0B0B"/>
+                </a:solidFill>
+                <a:latin typeface="Calibri"/>
+              </a:rPr>
+              <a:t>MinSet size: proven bounds 6,193–6,325, a gap of 2.1%; not computed exactly.</a:t>
+            </a:r>
+          </a:p>
+        </p:txBody>
+      </p:sp>
+      <p:sp>
+        <p:nvSpPr>
+          <p:cNvPr id="13" name="Rounded Rectangle 12"/>
+          <p:cNvSpPr/>
+          <p:nvPr/>
+        </p:nvSpPr>
+        <p:spPr>
+          <a:xfrm>
+            <a:off x="640080" y="3877056"/>
+            <a:ext cx="1645920" cy="548640"/>
+          </a:xfrm>
+          <a:prstGeom prst="roundRect">
+            <a:avLst/>
+          </a:prstGeom>
+          <a:solidFill>
+            <a:srgbClr val="1BAF7A"/>
+          </a:solidFill>
+          <a:ln>
+            <a:noFill/>
+          </a:ln>
+          <a:effectLst/>
+        </p:spPr>
+        <p:style>
+          <a:lnRef idx="1">
+            <a:schemeClr val="accent1"/>
+          </a:lnRef>
+          <a:fillRef idx="3">
+            <a:schemeClr val="accent1"/>
+          </a:fillRef>
+          <a:effectRef idx="2">
+            <a:schemeClr val="accent1"/>
+          </a:effectRef>
+          <a:fontRef idx="minor">
+            <a:schemeClr val="lt1"/>
+          </a:fontRef>
+        </p:style>
+        <p:txBody>
+          <a:bodyPr rtlCol="0" anchor="ctr"/>
+          <a:lstStyle/>
+          <a:p>
+            <a:pPr algn="ctr"/>
+            <a:r>
+              <a:rPr sz="1600" b="1">
+                <a:solidFill>
+                  <a:srgbClr val="FCFCFB"/>
+                </a:solidFill>
+                <a:latin typeface="Calibri"/>
+              </a:rPr>
+              <a:t>Good</a:t>
+            </a:r>
+          </a:p>
+        </p:txBody>
+      </p:sp>
+      <p:sp>
+        <p:nvSpPr>
+          <p:cNvPr id="14" name="TextBox 13"/>
+          <p:cNvSpPr txBox="1"/>
+          <p:nvPr/>
+        </p:nvSpPr>
+        <p:spPr>
+          <a:xfrm>
+            <a:off x="2514600" y="3922776"/>
+            <a:ext cx="9326880" cy="548640"/>
+          </a:xfrm>
+          <a:prstGeom prst="rect">
+            <a:avLst/>
+          </a:prstGeom>
+          <a:noFill/>
+        </p:spPr>
+        <p:txBody>
+          <a:bodyPr wrap="square" anchor="t" lIns="45720" rIns="45720">
+            <a:spAutoFit/>
+          </a:bodyPr>
+          <a:lstStyle/>
+          <a:p>
+            <a:pPr algn="l">
+              <a:spcAft>
+                <a:spcPts val="810"/>
+              </a:spcAft>
+            </a:pPr>
+            <a:r>
+              <a:rPr sz="1800" b="0">
+                <a:solidFill>
+                  <a:srgbClr val="0B0B0B"/>
+                </a:solidFill>
+                <a:latin typeface="Calibri"/>
+              </a:rPr>
+              <a:t>Graur’s most certain words are the most central; two marks out of 1,419 uncertain in our transcription.</a:t>
+            </a:r>
+          </a:p>
+        </p:txBody>
+      </p:sp>
+      <p:sp>
+        <p:nvSpPr>
+          <p:cNvPr id="15" name="Rounded Rectangle 14"/>
+          <p:cNvSpPr/>
+          <p:nvPr/>
+        </p:nvSpPr>
+        <p:spPr>
+          <a:xfrm>
+            <a:off x="640080" y="4590288"/>
+            <a:ext cx="1645920" cy="548640"/>
+          </a:xfrm>
+          <a:prstGeom prst="roundRect">
+            <a:avLst/>
+          </a:prstGeom>
+          <a:solidFill>
+            <a:srgbClr val="EB6834"/>
+          </a:solidFill>
+          <a:ln>
+            <a:noFill/>
+          </a:ln>
+          <a:effectLst/>
+        </p:spPr>
+        <p:style>
+          <a:lnRef idx="1">
+            <a:schemeClr val="accent1"/>
+          </a:lnRef>
+          <a:fillRef idx="3">
+            <a:schemeClr val="accent1"/>
+          </a:fillRef>
+          <a:effectRef idx="2">
+            <a:schemeClr val="accent1"/>
+          </a:effectRef>
+          <a:fontRef idx="minor">
+            <a:schemeClr val="lt1"/>
+          </a:fontRef>
+        </p:style>
+        <p:txBody>
+          <a:bodyPr rtlCol="0" anchor="ctr"/>
+          <a:lstStyle/>
+          <a:p>
+            <a:pPr algn="ctr"/>
+            <a:r>
+              <a:rPr sz="1600" b="1">
+                <a:solidFill>
+                  <a:srgbClr val="FCFCFB"/>
+                </a:solidFill>
+                <a:latin typeface="Calibri"/>
+              </a:rPr>
+              <a:t>Indicative</a:t>
+            </a:r>
+          </a:p>
+        </p:txBody>
+      </p:sp>
+      <p:sp>
+        <p:nvSpPr>
+          <p:cNvPr id="16" name="TextBox 15"/>
+          <p:cNvSpPr txBox="1"/>
+          <p:nvPr/>
+        </p:nvSpPr>
+        <p:spPr>
+          <a:xfrm>
+            <a:off x="2514600" y="4636008"/>
+            <a:ext cx="9326880" cy="548640"/>
+          </a:xfrm>
+          <a:prstGeom prst="rect">
+            <a:avLst/>
+          </a:prstGeom>
+          <a:noFill/>
+        </p:spPr>
+        <p:txBody>
+          <a:bodyPr wrap="square" anchor="t" lIns="45720" rIns="45720">
+            <a:spAutoFit/>
+          </a:bodyPr>
+          <a:lstStyle/>
+          <a:p>
+            <a:pPr algn="l">
+              <a:spcAft>
+                <a:spcPts val="810"/>
+              </a:spcAft>
+            </a:pPr>
+            <a:r>
+              <a:rPr sz="1800" b="0">
+                <a:solidFill>
+                  <a:srgbClr val="0B0B0B"/>
+                </a:solidFill>
+                <a:latin typeface="Calibri"/>
+              </a:rPr>
+              <a:t>Etymological contrast: part of the vocabulary is unclassified.</a:t>
+            </a:r>
+          </a:p>
+        </p:txBody>
+      </p:sp>
+      <p:sp>
+        <p:nvSpPr>
+          <p:cNvPr id="17" name="Rounded Rectangle 16"/>
+          <p:cNvSpPr/>
+          <p:nvPr/>
+        </p:nvSpPr>
+        <p:spPr>
+          <a:xfrm>
+            <a:off x="640080" y="5303520"/>
+            <a:ext cx="1645920" cy="548640"/>
+          </a:xfrm>
+          <a:prstGeom prst="roundRect">
+            <a:avLst/>
+          </a:prstGeom>
+          <a:solidFill>
+            <a:srgbClr val="8A8984"/>
+          </a:solidFill>
+          <a:ln>
+            <a:noFill/>
+          </a:ln>
+          <a:effectLst/>
+        </p:spPr>
+        <p:style>
+          <a:lnRef idx="1">
+            <a:schemeClr val="accent1"/>
+          </a:lnRef>
+          <a:fillRef idx="3">
+            <a:schemeClr val="accent1"/>
+          </a:fillRef>
+          <a:effectRef idx="2">
+            <a:schemeClr val="accent1"/>
+          </a:effectRef>
+          <a:fontRef idx="minor">
+            <a:schemeClr val="lt1"/>
+          </a:fontRef>
+        </p:style>
+        <p:txBody>
+          <a:bodyPr rtlCol="0" anchor="ctr"/>
+          <a:lstStyle/>
+          <a:p>
+            <a:pPr algn="ctr"/>
+            <a:r>
+              <a:rPr sz="1600" b="1">
+                <a:solidFill>
+                  <a:srgbClr val="FCFCFB"/>
+                </a:solidFill>
+                <a:latin typeface="Calibri"/>
+              </a:rPr>
+              <a:t>Scope</a:t>
+            </a:r>
+          </a:p>
+        </p:txBody>
+      </p:sp>
+      <p:sp>
+        <p:nvSpPr>
+          <p:cNvPr id="18" name="TextBox 17"/>
+          <p:cNvSpPr txBox="1"/>
+          <p:nvPr/>
+        </p:nvSpPr>
+        <p:spPr>
+          <a:xfrm>
+            <a:off x="2514600" y="5349240"/>
+            <a:ext cx="9326880" cy="548640"/>
+          </a:xfrm>
+          <a:prstGeom prst="rect">
+            <a:avLst/>
+          </a:prstGeom>
+          <a:noFill/>
+        </p:spPr>
+        <p:txBody>
+          <a:bodyPr wrap="square" anchor="t" lIns="45720" rIns="45720">
+            <a:spAutoFit/>
+          </a:bodyPr>
+          <a:lstStyle/>
+          <a:p>
+            <a:pPr algn="l">
+              <a:spcAft>
+                <a:spcPts val="810"/>
+              </a:spcAft>
+            </a:pPr>
+            <a:r>
+              <a:rPr sz="1800" b="0">
+                <a:solidFill>
+                  <a:srgbClr val="0B0B0B"/>
+                </a:solidFill>
+                <a:latin typeface="Calibri"/>
+              </a:rPr>
+              <a:t>One dictionary, one edition, first senses only.</a:t>
+            </a:r>
+          </a:p>
+        </p:txBody>
+      </p:sp>
+    </p:spTree>
+  </p:cSld>
+  <p:clrMapOvr>
+    <a:masterClrMapping/>
+  </p:clrMapOvr>
+</p:sld>
+</file>
+
+<file path=ppt/slides/slide15.xml><?xml version="1.0" encoding="utf-8"?>
+<p:sld xmlns:a="http://schemas.openxmlformats.org/drawingml/2006/main" xmlns:p="http://schemas.openxmlformats.org/presentationml/2006/main" xmlns:r="http://schemas.openxmlformats.org/officeDocument/2006/relationships">
+  <p:cSld>
+    <p:bg>
+      <p:bgPr>
+        <a:solidFill>
+          <a:srgbClr val="FCFCFB"/>
+        </a:solidFill>
+        <a:effectLst/>
+      </p:bgPr>
+    </p:bg>
+    <p:spTree>
+      <p:nvGrpSpPr>
+        <p:cNvPr id="1" name=""/>
+        <p:cNvGrpSpPr/>
+        <p:nvPr/>
+      </p:nvGrpSpPr>
+      <p:grpSpPr/>
+      <p:pic>
+        <p:nvPicPr>
+          <p:cNvPr id="2" name="Picture 1" descr="logo_consilr.png"/>
+          <p:cNvPicPr>
+            <a:picLocks noChangeAspect="1"/>
+          </p:cNvPicPr>
+          <p:nvPr/>
+        </p:nvPicPr>
+        <p:blipFill>
+          <a:blip r:embed="rId2"/>
+          <a:stretch>
+            <a:fillRect/>
+          </a:stretch>
+        </p:blipFill>
+        <p:spPr>
+          <a:xfrm>
+            <a:off x="10591495" y="256032"/>
+            <a:ext cx="1311965" cy="502920"/>
+          </a:xfrm>
+          <a:prstGeom prst="rect">
+            <a:avLst/>
+          </a:prstGeom>
+        </p:spPr>
+      </p:pic>
+      <p:sp>
+        <p:nvSpPr>
+          <p:cNvPr id="3" name="TextBox 2"/>
+          <p:cNvSpPr txBox="1"/>
+          <p:nvPr/>
+        </p:nvSpPr>
+        <p:spPr>
+          <a:xfrm>
+            <a:off x="640080" y="320040"/>
+            <a:ext cx="9144000" cy="365760"/>
+          </a:xfrm>
+          <a:prstGeom prst="rect">
+            <a:avLst/>
+          </a:prstGeom>
+          <a:noFill/>
+        </p:spPr>
+        <p:txBody>
+          <a:bodyPr wrap="square" anchor="t" lIns="45720" rIns="45720">
+            <a:spAutoFit/>
+          </a:bodyPr>
+          <a:lstStyle/>
+          <a:p>
+            <a:pPr algn="l">
+              <a:spcAft>
+                <a:spcPts val="585"/>
+              </a:spcAft>
+            </a:pPr>
+            <a:r>
+              <a:rPr sz="1300" b="1">
+                <a:solidFill>
+                  <a:srgbClr val="2A78D6"/>
+                </a:solidFill>
+                <a:latin typeface="Calibri"/>
+              </a:rPr>
               <a:t>SUMMARY</a:t>
             </a:r>
           </a:p>
@@ -10736,7 +11138,7 @@
                 </a:solidFill>
                 <a:latin typeface="Calibri"/>
               </a:rPr>
-              <a:t>RESULT 2</a:t>
+              <a:t>COMPARISON, SAME PROCEDURE</a:t>
             </a:r>
           </a:p>
         </p:txBody>
@@ -10775,7 +11177,7 @@
                 </a:solidFill>
                 <a:latin typeface="Calibri"/>
               </a:rPr>
-              <a:t>Why? Definition by synonym</a:t>
+              <a:t>The DEX stands apart from dictionaries of 11 other languages</a:t>
             </a:r>
           </a:p>
         </p:txBody>
@@ -10854,334 +11256,40 @@
           </a:p>
         </p:txBody>
       </p:sp>
-      <p:sp>
-        <p:nvSpPr>
-          <p:cNvPr id="7" name="Rounded Rectangle 6"/>
-          <p:cNvSpPr/>
-          <p:nvPr/>
-        </p:nvSpPr>
-        <p:spPr>
-          <a:xfrm>
-            <a:off x="640080" y="1783080"/>
-            <a:ext cx="3474720" cy="914400"/>
-          </a:xfrm>
-          <a:prstGeom prst="roundRect">
-            <a:avLst/>
-          </a:prstGeom>
-          <a:solidFill>
-            <a:srgbClr val="E8F1FB"/>
-          </a:solidFill>
-          <a:ln>
-            <a:noFill/>
-          </a:ln>
-          <a:effectLst/>
-        </p:spPr>
-        <p:style>
-          <a:lnRef idx="1">
-            <a:schemeClr val="accent1"/>
-          </a:lnRef>
-          <a:fillRef idx="3">
-            <a:schemeClr val="accent1"/>
-          </a:fillRef>
-          <a:effectRef idx="2">
-            <a:schemeClr val="accent1"/>
-          </a:effectRef>
-          <a:fontRef idx="minor">
-            <a:schemeClr val="lt1"/>
-          </a:fontRef>
-        </p:style>
-        <p:txBody>
-          <a:bodyPr rtlCol="0" anchor="ctr"/>
-          <a:lstStyle/>
-          <a:p>
-            <a:pPr algn="ctr"/>
-            <a:r>
-              <a:rPr sz="2400" i="1">
-                <a:solidFill>
-                  <a:srgbClr val="0B0B0B"/>
-                </a:solidFill>
-                <a:latin typeface="Calibri"/>
-              </a:rPr>
-              <a:t>arbore  ⇄  copac</a:t>
-            </a:r>
-          </a:p>
-        </p:txBody>
-      </p:sp>
-      <p:sp>
-        <p:nvSpPr>
-          <p:cNvPr id="8" name="Rounded Rectangle 7"/>
-          <p:cNvSpPr/>
-          <p:nvPr/>
-        </p:nvSpPr>
-        <p:spPr>
-          <a:xfrm>
-            <a:off x="4389120" y="1783080"/>
-            <a:ext cx="3474720" cy="914400"/>
-          </a:xfrm>
-          <a:prstGeom prst="roundRect">
-            <a:avLst/>
-          </a:prstGeom>
-          <a:solidFill>
-            <a:srgbClr val="E8F1FB"/>
-          </a:solidFill>
-          <a:ln>
-            <a:noFill/>
-          </a:ln>
-          <a:effectLst/>
-        </p:spPr>
-        <p:style>
-          <a:lnRef idx="1">
-            <a:schemeClr val="accent1"/>
-          </a:lnRef>
-          <a:fillRef idx="3">
-            <a:schemeClr val="accent1"/>
-          </a:fillRef>
-          <a:effectRef idx="2">
-            <a:schemeClr val="accent1"/>
-          </a:effectRef>
-          <a:fontRef idx="minor">
-            <a:schemeClr val="lt1"/>
-          </a:fontRef>
-        </p:style>
-        <p:txBody>
-          <a:bodyPr rtlCol="0" anchor="ctr"/>
-          <a:lstStyle/>
-          <a:p>
-            <a:pPr algn="ctr"/>
-            <a:r>
-              <a:rPr sz="2400" i="1">
-                <a:solidFill>
-                  <a:srgbClr val="0B0B0B"/>
-                </a:solidFill>
-                <a:latin typeface="Calibri"/>
-              </a:rPr>
-              <a:t>amabil  ⇄  binevoitor</a:t>
-            </a:r>
-          </a:p>
-        </p:txBody>
-      </p:sp>
-      <p:sp>
-        <p:nvSpPr>
-          <p:cNvPr id="9" name="Rounded Rectangle 8"/>
-          <p:cNvSpPr/>
-          <p:nvPr/>
-        </p:nvSpPr>
-        <p:spPr>
-          <a:xfrm>
-            <a:off x="8138159" y="1783080"/>
-            <a:ext cx="3474720" cy="914400"/>
-          </a:xfrm>
-          <a:prstGeom prst="roundRect">
-            <a:avLst/>
-          </a:prstGeom>
-          <a:solidFill>
-            <a:srgbClr val="E8F1FB"/>
-          </a:solidFill>
-          <a:ln>
-            <a:noFill/>
-          </a:ln>
-          <a:effectLst/>
-        </p:spPr>
-        <p:style>
-          <a:lnRef idx="1">
-            <a:schemeClr val="accent1"/>
-          </a:lnRef>
-          <a:fillRef idx="3">
-            <a:schemeClr val="accent1"/>
-          </a:fillRef>
-          <a:effectRef idx="2">
-            <a:schemeClr val="accent1"/>
-          </a:effectRef>
-          <a:fontRef idx="minor">
-            <a:schemeClr val="lt1"/>
-          </a:fontRef>
-        </p:style>
-        <p:txBody>
-          <a:bodyPr rtlCol="0" anchor="ctr"/>
-          <a:lstStyle/>
-          <a:p>
-            <a:pPr algn="ctr"/>
-            <a:r>
-              <a:rPr sz="2400" i="1">
-                <a:solidFill>
-                  <a:srgbClr val="0B0B0B"/>
-                </a:solidFill>
-                <a:latin typeface="Calibri"/>
-              </a:rPr>
-              <a:t>primejdie  ⇄  risc</a:t>
-            </a:r>
-          </a:p>
-        </p:txBody>
-      </p:sp>
-      <p:sp>
-        <p:nvSpPr>
-          <p:cNvPr id="10" name="Rounded Rectangle 9"/>
-          <p:cNvSpPr/>
-          <p:nvPr/>
-        </p:nvSpPr>
-        <p:spPr>
-          <a:xfrm>
-            <a:off x="640080" y="2926080"/>
-            <a:ext cx="3474720" cy="914400"/>
-          </a:xfrm>
-          <a:prstGeom prst="roundRect">
-            <a:avLst/>
-          </a:prstGeom>
-          <a:solidFill>
-            <a:srgbClr val="E8F1FB"/>
-          </a:solidFill>
-          <a:ln>
-            <a:noFill/>
-          </a:ln>
-          <a:effectLst/>
-        </p:spPr>
-        <p:style>
-          <a:lnRef idx="1">
-            <a:schemeClr val="accent1"/>
-          </a:lnRef>
-          <a:fillRef idx="3">
-            <a:schemeClr val="accent1"/>
-          </a:fillRef>
-          <a:effectRef idx="2">
-            <a:schemeClr val="accent1"/>
-          </a:effectRef>
-          <a:fontRef idx="minor">
-            <a:schemeClr val="lt1"/>
-          </a:fontRef>
-        </p:style>
-        <p:txBody>
-          <a:bodyPr rtlCol="0" anchor="ctr"/>
-          <a:lstStyle/>
-          <a:p>
-            <a:pPr algn="ctr"/>
-            <a:r>
-              <a:rPr sz="2400" i="1">
-                <a:solidFill>
-                  <a:srgbClr val="0B0B0B"/>
-                </a:solidFill>
-                <a:latin typeface="Calibri"/>
-              </a:rPr>
-              <a:t>balenă  ⇄  chit</a:t>
-            </a:r>
-          </a:p>
-        </p:txBody>
-      </p:sp>
-      <p:sp>
-        <p:nvSpPr>
-          <p:cNvPr id="11" name="Rounded Rectangle 10"/>
-          <p:cNvSpPr/>
-          <p:nvPr/>
-        </p:nvSpPr>
-        <p:spPr>
-          <a:xfrm>
-            <a:off x="4389120" y="2926080"/>
-            <a:ext cx="3474720" cy="914400"/>
-          </a:xfrm>
-          <a:prstGeom prst="roundRect">
-            <a:avLst/>
-          </a:prstGeom>
-          <a:solidFill>
-            <a:srgbClr val="E8F1FB"/>
-          </a:solidFill>
-          <a:ln>
-            <a:noFill/>
-          </a:ln>
-          <a:effectLst/>
-        </p:spPr>
-        <p:style>
-          <a:lnRef idx="1">
-            <a:schemeClr val="accent1"/>
-          </a:lnRef>
-          <a:fillRef idx="3">
-            <a:schemeClr val="accent1"/>
-          </a:fillRef>
-          <a:effectRef idx="2">
-            <a:schemeClr val="accent1"/>
-          </a:effectRef>
-          <a:fontRef idx="minor">
-            <a:schemeClr val="lt1"/>
-          </a:fontRef>
-        </p:style>
-        <p:txBody>
-          <a:bodyPr rtlCol="0" anchor="ctr"/>
-          <a:lstStyle/>
-          <a:p>
-            <a:pPr algn="ctr"/>
-            <a:r>
-              <a:rPr sz="2400" i="1">
-                <a:solidFill>
-                  <a:srgbClr val="0B0B0B"/>
-                </a:solidFill>
-                <a:latin typeface="Calibri"/>
-              </a:rPr>
-              <a:t>capelă  ⇄  paraclis</a:t>
-            </a:r>
-          </a:p>
-        </p:txBody>
-      </p:sp>
-      <p:sp>
-        <p:nvSpPr>
-          <p:cNvPr id="12" name="Rounded Rectangle 11"/>
-          <p:cNvSpPr/>
-          <p:nvPr/>
-        </p:nvSpPr>
-        <p:spPr>
-          <a:xfrm>
-            <a:off x="8138159" y="2926080"/>
-            <a:ext cx="3474720" cy="914400"/>
-          </a:xfrm>
-          <a:prstGeom prst="roundRect">
-            <a:avLst/>
-          </a:prstGeom>
-          <a:solidFill>
-            <a:srgbClr val="E8F1FB"/>
-          </a:solidFill>
-          <a:ln>
-            <a:noFill/>
-          </a:ln>
-          <a:effectLst/>
-        </p:spPr>
-        <p:style>
-          <a:lnRef idx="1">
-            <a:schemeClr val="accent1"/>
-          </a:lnRef>
-          <a:fillRef idx="3">
-            <a:schemeClr val="accent1"/>
-          </a:fillRef>
-          <a:effectRef idx="2">
-            <a:schemeClr val="accent1"/>
-          </a:effectRef>
-          <a:fontRef idx="minor">
-            <a:schemeClr val="lt1"/>
-          </a:fontRef>
-        </p:style>
-        <p:txBody>
-          <a:bodyPr rtlCol="0" anchor="ctr"/>
-          <a:lstStyle/>
-          <a:p>
-            <a:pPr algn="ctr"/>
-            <a:r>
-              <a:rPr sz="2400" i="1">
-                <a:solidFill>
-                  <a:srgbClr val="0B0B0B"/>
-                </a:solidFill>
-                <a:latin typeface="Calibri"/>
-              </a:rPr>
-              <a:t>apuca  ⇄  înșfăca</a:t>
-            </a:r>
-          </a:p>
-        </p:txBody>
-      </p:sp>
-      <p:sp>
-        <p:nvSpPr>
-          <p:cNvPr id="13" name="TextBox 12"/>
+      <p:pic>
+        <p:nvPicPr>
+          <p:cNvPr id="7" name="Picture 6" descr="fig5_crossling.png"/>
+          <p:cNvPicPr>
+            <a:picLocks noChangeAspect="1"/>
+          </p:cNvPicPr>
+          <p:nvPr/>
+        </p:nvPicPr>
+        <p:blipFill>
+          <a:blip r:embed="rId3"/>
+          <a:stretch>
+            <a:fillRect/>
+          </a:stretch>
+        </p:blipFill>
+        <p:spPr>
+          <a:xfrm>
+            <a:off x="457200" y="1600200"/>
+            <a:ext cx="7680960" cy="4544313"/>
+          </a:xfrm>
+          <a:prstGeom prst="rect">
+            <a:avLst/>
+          </a:prstGeom>
+        </p:spPr>
+      </p:pic>
+      <p:sp>
+        <p:nvSpPr>
+          <p:cNvPr id="8" name="TextBox 7"/>
           <p:cNvSpPr txBox="1"/>
           <p:nvPr/>
         </p:nvSpPr>
         <p:spPr>
           <a:xfrm>
-            <a:off x="640080" y="4251960"/>
-            <a:ext cx="10972800" cy="1828800"/>
+            <a:off x="8412480" y="1737360"/>
+            <a:ext cx="3566160" cy="4206240"/>
           </a:xfrm>
           <a:prstGeom prst="rect">
             <a:avLst/>
@@ -11196,58 +11304,83 @@
           <a:p>
             <a:pPr algn="l">
               <a:spcAft>
-                <a:spcPts val="900"/>
+                <a:spcPts val="765"/>
               </a:spcAft>
             </a:pPr>
             <a:r>
-              <a:rPr sz="2000" b="1" i="0">
+              <a:rPr sz="3000" b="1" i="0">
                 <a:solidFill>
                   <a:srgbClr val="2A78D6"/>
                 </a:solidFill>
                 <a:latin typeface="Calibri"/>
               </a:rPr>
-              <a:t>8,761 pairs of words define each other</a:t>
-            </a:r>
-            <a:r>
-              <a:rPr sz="2000" b="0">
+              <a:t>28%</a:t>
+            </a:r>
+            <a:r>
+              <a:rPr sz="1700" b="0">
                 <a:solidFill>
                   <a:srgbClr val="0B0B0B"/>
                 </a:solidFill>
                 <a:latin typeface="Calibri"/>
               </a:rPr>
-              <a:t> (29% share a stem; most others are synonyms).</a:t>
+              <a:t> of the DEX Kernel is needed as MinSet</a:t>
             </a:r>
           </a:p>
           <a:p>
             <a:pPr algn="l">
               <a:spcAft>
-                <a:spcPts val="900"/>
+                <a:spcPts val="765"/>
               </a:spcAft>
             </a:pPr>
             <a:r>
-              <a:rPr sz="2000" b="0">
+              <a:rPr sz="3000" b="1" i="0">
+                <a:solidFill>
+                  <a:srgbClr val="52514E"/>
+                </a:solidFill>
+                <a:latin typeface="Calibri"/>
+              </a:rPr>
+              <a:t>10–16%</a:t>
+            </a:r>
+            <a:r>
+              <a:rPr sz="1700" b="0">
                 <a:solidFill>
                   <a:srgbClr val="0B0B0B"/>
                 </a:solidFill>
                 <a:latin typeface="Calibri"/>
               </a:rPr>
-              <a:t>Each pair forces one word into the MinSet: 98% of the disjoint cycles are such pairs.</a:t>
+              <a:t> in all other dictionaries</a:t>
             </a:r>
           </a:p>
           <a:p>
             <a:pPr algn="l">
               <a:spcAft>
-                <a:spcPts val="900"/>
+                <a:spcPts val="765"/>
               </a:spcAft>
             </a:pPr>
             <a:r>
-              <a:rPr sz="2000" b="0">
+              <a:rPr sz="1700" b="0">
                 <a:solidFill>
                   <a:srgbClr val="0B0B0B"/>
                 </a:solidFill>
                 <a:latin typeface="Calibri"/>
               </a:rPr>
-              <a:t>English learner dictionaries use a controlled defining vocabulary; the DEX defines by synonym.</a:t>
+              <a:t>Reciprocal pairs: 5–21 times more frequent in the DEX.</a:t>
+            </a:r>
+          </a:p>
+          <a:p>
+            <a:pPr algn="l">
+              <a:spcAft>
+                <a:spcPts val="765"/>
+              </a:spcAft>
+            </a:pPr>
+            <a:r>
+              <a:rPr sz="1700" b="0">
+                <a:solidFill>
+                  <a:srgbClr val="0B0B0B"/>
+                </a:solidFill>
+                <a:latin typeface="Calibri"/>
+              </a:rPr>
+              <a:t>Italian, Spanish, Portuguese and French behave like German or Russian: not a Romance property.</a:t>
             </a:r>
           </a:p>
         </p:txBody>
@@ -11336,7 +11469,7 @@
                 </a:solidFill>
                 <a:latin typeface="Calibri"/>
               </a:rPr>
-              <a:t>ROBUSTNESS</a:t>
+              <a:t>RESULT 2</a:t>
             </a:r>
           </a:p>
         </p:txBody>
@@ -11375,7 +11508,7 @@
                 </a:solidFill>
                 <a:latin typeface="Calibri"/>
               </a:rPr>
-              <a:t>The conclusion does not depend on the AI</a:t>
+              <a:t>Why? Definition by synonym</a:t>
             </a:r>
           </a:p>
         </p:txBody>
@@ -11454,40 +11587,334 @@
           </a:p>
         </p:txBody>
       </p:sp>
-      <p:pic>
-        <p:nvPicPr>
-          <p:cNvPr id="7" name="Picture 6" descr="fig3_robustness.png"/>
-          <p:cNvPicPr>
-            <a:picLocks noChangeAspect="1"/>
-          </p:cNvPicPr>
-          <p:nvPr/>
-        </p:nvPicPr>
-        <p:blipFill>
-          <a:blip r:embed="rId3"/>
-          <a:stretch>
-            <a:fillRect/>
-          </a:stretch>
-        </p:blipFill>
-        <p:spPr>
-          <a:xfrm>
-            <a:off x="640080" y="1737360"/>
-            <a:ext cx="6949440" cy="2745705"/>
-          </a:xfrm>
-          <a:prstGeom prst="rect">
-            <a:avLst/>
-          </a:prstGeom>
-        </p:spPr>
-      </p:pic>
-      <p:sp>
-        <p:nvSpPr>
-          <p:cNvPr id="8" name="TextBox 7"/>
+      <p:sp>
+        <p:nvSpPr>
+          <p:cNvPr id="7" name="Rounded Rectangle 6"/>
+          <p:cNvSpPr/>
+          <p:nvPr/>
+        </p:nvSpPr>
+        <p:spPr>
+          <a:xfrm>
+            <a:off x="640080" y="1783080"/>
+            <a:ext cx="3474720" cy="914400"/>
+          </a:xfrm>
+          <a:prstGeom prst="roundRect">
+            <a:avLst/>
+          </a:prstGeom>
+          <a:solidFill>
+            <a:srgbClr val="E8F1FB"/>
+          </a:solidFill>
+          <a:ln>
+            <a:noFill/>
+          </a:ln>
+          <a:effectLst/>
+        </p:spPr>
+        <p:style>
+          <a:lnRef idx="1">
+            <a:schemeClr val="accent1"/>
+          </a:lnRef>
+          <a:fillRef idx="3">
+            <a:schemeClr val="accent1"/>
+          </a:fillRef>
+          <a:effectRef idx="2">
+            <a:schemeClr val="accent1"/>
+          </a:effectRef>
+          <a:fontRef idx="minor">
+            <a:schemeClr val="lt1"/>
+          </a:fontRef>
+        </p:style>
+        <p:txBody>
+          <a:bodyPr rtlCol="0" anchor="ctr"/>
+          <a:lstStyle/>
+          <a:p>
+            <a:pPr algn="ctr"/>
+            <a:r>
+              <a:rPr sz="2400" i="1">
+                <a:solidFill>
+                  <a:srgbClr val="0B0B0B"/>
+                </a:solidFill>
+                <a:latin typeface="Calibri"/>
+              </a:rPr>
+              <a:t>arbore  ⇄  copac</a:t>
+            </a:r>
+          </a:p>
+        </p:txBody>
+      </p:sp>
+      <p:sp>
+        <p:nvSpPr>
+          <p:cNvPr id="8" name="Rounded Rectangle 7"/>
+          <p:cNvSpPr/>
+          <p:nvPr/>
+        </p:nvSpPr>
+        <p:spPr>
+          <a:xfrm>
+            <a:off x="4389120" y="1783080"/>
+            <a:ext cx="3474720" cy="914400"/>
+          </a:xfrm>
+          <a:prstGeom prst="roundRect">
+            <a:avLst/>
+          </a:prstGeom>
+          <a:solidFill>
+            <a:srgbClr val="E8F1FB"/>
+          </a:solidFill>
+          <a:ln>
+            <a:noFill/>
+          </a:ln>
+          <a:effectLst/>
+        </p:spPr>
+        <p:style>
+          <a:lnRef idx="1">
+            <a:schemeClr val="accent1"/>
+          </a:lnRef>
+          <a:fillRef idx="3">
+            <a:schemeClr val="accent1"/>
+          </a:fillRef>
+          <a:effectRef idx="2">
+            <a:schemeClr val="accent1"/>
+          </a:effectRef>
+          <a:fontRef idx="minor">
+            <a:schemeClr val="lt1"/>
+          </a:fontRef>
+        </p:style>
+        <p:txBody>
+          <a:bodyPr rtlCol="0" anchor="ctr"/>
+          <a:lstStyle/>
+          <a:p>
+            <a:pPr algn="ctr"/>
+            <a:r>
+              <a:rPr sz="2400" i="1">
+                <a:solidFill>
+                  <a:srgbClr val="0B0B0B"/>
+                </a:solidFill>
+                <a:latin typeface="Calibri"/>
+              </a:rPr>
+              <a:t>amabil  ⇄  binevoitor</a:t>
+            </a:r>
+          </a:p>
+        </p:txBody>
+      </p:sp>
+      <p:sp>
+        <p:nvSpPr>
+          <p:cNvPr id="9" name="Rounded Rectangle 8"/>
+          <p:cNvSpPr/>
+          <p:nvPr/>
+        </p:nvSpPr>
+        <p:spPr>
+          <a:xfrm>
+            <a:off x="8138159" y="1783080"/>
+            <a:ext cx="3474720" cy="914400"/>
+          </a:xfrm>
+          <a:prstGeom prst="roundRect">
+            <a:avLst/>
+          </a:prstGeom>
+          <a:solidFill>
+            <a:srgbClr val="E8F1FB"/>
+          </a:solidFill>
+          <a:ln>
+            <a:noFill/>
+          </a:ln>
+          <a:effectLst/>
+        </p:spPr>
+        <p:style>
+          <a:lnRef idx="1">
+            <a:schemeClr val="accent1"/>
+          </a:lnRef>
+          <a:fillRef idx="3">
+            <a:schemeClr val="accent1"/>
+          </a:fillRef>
+          <a:effectRef idx="2">
+            <a:schemeClr val="accent1"/>
+          </a:effectRef>
+          <a:fontRef idx="minor">
+            <a:schemeClr val="lt1"/>
+          </a:fontRef>
+        </p:style>
+        <p:txBody>
+          <a:bodyPr rtlCol="0" anchor="ctr"/>
+          <a:lstStyle/>
+          <a:p>
+            <a:pPr algn="ctr"/>
+            <a:r>
+              <a:rPr sz="2400" i="1">
+                <a:solidFill>
+                  <a:srgbClr val="0B0B0B"/>
+                </a:solidFill>
+                <a:latin typeface="Calibri"/>
+              </a:rPr>
+              <a:t>primejdie  ⇄  risc</a:t>
+            </a:r>
+          </a:p>
+        </p:txBody>
+      </p:sp>
+      <p:sp>
+        <p:nvSpPr>
+          <p:cNvPr id="10" name="Rounded Rectangle 9"/>
+          <p:cNvSpPr/>
+          <p:nvPr/>
+        </p:nvSpPr>
+        <p:spPr>
+          <a:xfrm>
+            <a:off x="640080" y="2926080"/>
+            <a:ext cx="3474720" cy="914400"/>
+          </a:xfrm>
+          <a:prstGeom prst="roundRect">
+            <a:avLst/>
+          </a:prstGeom>
+          <a:solidFill>
+            <a:srgbClr val="E8F1FB"/>
+          </a:solidFill>
+          <a:ln>
+            <a:noFill/>
+          </a:ln>
+          <a:effectLst/>
+        </p:spPr>
+        <p:style>
+          <a:lnRef idx="1">
+            <a:schemeClr val="accent1"/>
+          </a:lnRef>
+          <a:fillRef idx="3">
+            <a:schemeClr val="accent1"/>
+          </a:fillRef>
+          <a:effectRef idx="2">
+            <a:schemeClr val="accent1"/>
+          </a:effectRef>
+          <a:fontRef idx="minor">
+            <a:schemeClr val="lt1"/>
+          </a:fontRef>
+        </p:style>
+        <p:txBody>
+          <a:bodyPr rtlCol="0" anchor="ctr"/>
+          <a:lstStyle/>
+          <a:p>
+            <a:pPr algn="ctr"/>
+            <a:r>
+              <a:rPr sz="2400" i="1">
+                <a:solidFill>
+                  <a:srgbClr val="0B0B0B"/>
+                </a:solidFill>
+                <a:latin typeface="Calibri"/>
+              </a:rPr>
+              <a:t>balenă  ⇄  chit</a:t>
+            </a:r>
+          </a:p>
+        </p:txBody>
+      </p:sp>
+      <p:sp>
+        <p:nvSpPr>
+          <p:cNvPr id="11" name="Rounded Rectangle 10"/>
+          <p:cNvSpPr/>
+          <p:nvPr/>
+        </p:nvSpPr>
+        <p:spPr>
+          <a:xfrm>
+            <a:off x="4389120" y="2926080"/>
+            <a:ext cx="3474720" cy="914400"/>
+          </a:xfrm>
+          <a:prstGeom prst="roundRect">
+            <a:avLst/>
+          </a:prstGeom>
+          <a:solidFill>
+            <a:srgbClr val="E8F1FB"/>
+          </a:solidFill>
+          <a:ln>
+            <a:noFill/>
+          </a:ln>
+          <a:effectLst/>
+        </p:spPr>
+        <p:style>
+          <a:lnRef idx="1">
+            <a:schemeClr val="accent1"/>
+          </a:lnRef>
+          <a:fillRef idx="3">
+            <a:schemeClr val="accent1"/>
+          </a:fillRef>
+          <a:effectRef idx="2">
+            <a:schemeClr val="accent1"/>
+          </a:effectRef>
+          <a:fontRef idx="minor">
+            <a:schemeClr val="lt1"/>
+          </a:fontRef>
+        </p:style>
+        <p:txBody>
+          <a:bodyPr rtlCol="0" anchor="ctr"/>
+          <a:lstStyle/>
+          <a:p>
+            <a:pPr algn="ctr"/>
+            <a:r>
+              <a:rPr sz="2400" i="1">
+                <a:solidFill>
+                  <a:srgbClr val="0B0B0B"/>
+                </a:solidFill>
+                <a:latin typeface="Calibri"/>
+              </a:rPr>
+              <a:t>capelă  ⇄  paraclis</a:t>
+            </a:r>
+          </a:p>
+        </p:txBody>
+      </p:sp>
+      <p:sp>
+        <p:nvSpPr>
+          <p:cNvPr id="12" name="Rounded Rectangle 11"/>
+          <p:cNvSpPr/>
+          <p:nvPr/>
+        </p:nvSpPr>
+        <p:spPr>
+          <a:xfrm>
+            <a:off x="8138159" y="2926080"/>
+            <a:ext cx="3474720" cy="914400"/>
+          </a:xfrm>
+          <a:prstGeom prst="roundRect">
+            <a:avLst/>
+          </a:prstGeom>
+          <a:solidFill>
+            <a:srgbClr val="E8F1FB"/>
+          </a:solidFill>
+          <a:ln>
+            <a:noFill/>
+          </a:ln>
+          <a:effectLst/>
+        </p:spPr>
+        <p:style>
+          <a:lnRef idx="1">
+            <a:schemeClr val="accent1"/>
+          </a:lnRef>
+          <a:fillRef idx="3">
+            <a:schemeClr val="accent1"/>
+          </a:fillRef>
+          <a:effectRef idx="2">
+            <a:schemeClr val="accent1"/>
+          </a:effectRef>
+          <a:fontRef idx="minor">
+            <a:schemeClr val="lt1"/>
+          </a:fontRef>
+        </p:style>
+        <p:txBody>
+          <a:bodyPr rtlCol="0" anchor="ctr"/>
+          <a:lstStyle/>
+          <a:p>
+            <a:pPr algn="ctr"/>
+            <a:r>
+              <a:rPr sz="2400" i="1">
+                <a:solidFill>
+                  <a:srgbClr val="0B0B0B"/>
+                </a:solidFill>
+                <a:latin typeface="Calibri"/>
+              </a:rPr>
+              <a:t>apuca  ⇄  înșfăca</a:t>
+            </a:r>
+          </a:p>
+        </p:txBody>
+      </p:sp>
+      <p:sp>
+        <p:nvSpPr>
+          <p:cNvPr id="13" name="TextBox 12"/>
           <p:cNvSpPr txBox="1"/>
           <p:nvPr/>
         </p:nvSpPr>
         <p:spPr>
           <a:xfrm>
-            <a:off x="7955279" y="1828800"/>
-            <a:ext cx="3840480" cy="4023360"/>
+            <a:off x="640080" y="4251960"/>
+            <a:ext cx="10972800" cy="1828800"/>
           </a:xfrm>
           <a:prstGeom prst="rect">
             <a:avLst/>
@@ -11502,58 +11929,58 @@
           <a:p>
             <a:pPr algn="l">
               <a:spcAft>
-                <a:spcPts val="855"/>
+                <a:spcPts val="900"/>
               </a:spcAft>
             </a:pPr>
             <a:r>
-              <a:rPr sz="1900" b="0">
+              <a:rPr sz="2000" b="1" i="0">
+                <a:solidFill>
+                  <a:srgbClr val="2A78D6"/>
+                </a:solidFill>
+                <a:latin typeface="Calibri"/>
+              </a:rPr>
+              <a:t>8,761 pairs of words define each other</a:t>
+            </a:r>
+            <a:r>
+              <a:rPr sz="2000" b="0">
                 <a:solidFill>
                   <a:srgbClr val="0B0B0B"/>
                 </a:solidFill>
                 <a:latin typeface="Calibri"/>
               </a:rPr>
-              <a:t>Three ways of resolving ambiguous forms: the most frequent lemma, the language model, all candidates.</a:t>
+              <a:t> (29% share a stem; most others are synonyms).</a:t>
             </a:r>
           </a:p>
           <a:p>
             <a:pPr algn="l">
               <a:spcAft>
-                <a:spcPts val="855"/>
+                <a:spcPts val="900"/>
               </a:spcAft>
             </a:pPr>
             <a:r>
-              <a:rPr sz="1900" b="1" i="0">
+              <a:rPr sz="2000" b="0">
                 <a:solidFill>
                   <a:srgbClr val="0B0B0B"/>
                 </a:solidFill>
                 <a:latin typeface="Calibri"/>
               </a:rPr>
-              <a:t>Same picture every time: </a:t>
-            </a:r>
-            <a:r>
-              <a:rPr sz="1900" b="0">
-                <a:solidFill>
-                  <a:srgbClr val="0B0B0B"/>
-                </a:solidFill>
-                <a:latin typeface="Calibri"/>
-              </a:rPr>
-              <a:t>a Kernel of 29–36% and a MinSet of 7.5–10.9%.</a:t>
+              <a:t>Each pair forces one word into the MinSet: 98% of the disjoint cycles are such pairs.</a:t>
             </a:r>
           </a:p>
           <a:p>
             <a:pPr algn="l">
               <a:spcAft>
-                <a:spcPts val="855"/>
+                <a:spcPts val="900"/>
               </a:spcAft>
             </a:pPr>
             <a:r>
-              <a:rPr sz="1900" b="0">
+              <a:rPr sz="2000" b="0">
                 <a:solidFill>
                   <a:srgbClr val="0B0B0B"/>
                 </a:solidFill>
                 <a:latin typeface="Calibri"/>
               </a:rPr>
-              <a:t>Correct lemmas reveal more reciprocal pairs.</a:t>
+              <a:t>English learner dictionaries use a controlled defining vocabulary; the DEX defines by synonym.</a:t>
             </a:r>
           </a:p>
         </p:txBody>
@@ -11642,7 +12069,7 @@
                 </a:solidFill>
                 <a:latin typeface="Calibri"/>
               </a:rPr>
-              <a:t>RESULT 3</a:t>
+              <a:t>ROBUSTNESS</a:t>
             </a:r>
           </a:p>
         </p:txBody>
@@ -11681,7 +12108,7 @@
                 </a:solidFill>
                 <a:latin typeface="Calibri"/>
               </a:rPr>
-              <a:t>The core is linguistically real</a:t>
+              <a:t>The conclusion does not depend on the AI</a:t>
             </a:r>
           </a:p>
         </p:txBody>
@@ -11762,7 +12189,7 @@
       </p:sp>
       <p:pic>
         <p:nvPicPr>
-          <p:cNvPr id="7" name="Picture 6" descr="fig2_enrichment.png"/>
+          <p:cNvPr id="7" name="Picture 6" descr="fig3_robustness.png"/>
           <p:cNvPicPr>
             <a:picLocks noChangeAspect="1"/>
           </p:cNvPicPr>
@@ -11776,8 +12203,8 @@
         </p:blipFill>
         <p:spPr>
           <a:xfrm>
-            <a:off x="548640" y="1691640"/>
-            <a:ext cx="7589520" cy="3095167"/>
+            <a:off x="640080" y="1737360"/>
+            <a:ext cx="6949440" cy="2745705"/>
           </a:xfrm>
           <a:prstGeom prst="rect">
             <a:avLst/>
@@ -11792,8 +12219,8 @@
         </p:nvSpPr>
         <p:spPr>
           <a:xfrm>
-            <a:off x="8412480" y="1828800"/>
-            <a:ext cx="3474720" cy="4023360"/>
+            <a:off x="7955279" y="1828800"/>
+            <a:ext cx="3840480" cy="4023360"/>
           </a:xfrm>
           <a:prstGeom prst="rect">
             <a:avLst/>
@@ -11808,83 +12235,58 @@
           <a:p>
             <a:pPr algn="l">
               <a:spcAft>
-                <a:spcPts val="810"/>
+                <a:spcPts val="855"/>
               </a:spcAft>
             </a:pPr>
             <a:r>
-              <a:rPr sz="3000" b="1" i="0">
-                <a:solidFill>
-                  <a:srgbClr val="2A78D6"/>
-                </a:solidFill>
-                <a:latin typeface="Calibri"/>
-              </a:rPr>
-              <a:t>98%</a:t>
-            </a:r>
-            <a:r>
-              <a:rPr sz="1800" b="0">
+              <a:rPr sz="1900" b="0">
                 <a:solidFill>
                   <a:srgbClr val="0B0B0B"/>
                 </a:solidFill>
                 <a:latin typeface="Calibri"/>
               </a:rPr>
-              <a:t> of the Swadesh list (about 200 basic meanings used in comparative linguistics) in the Kernel</a:t>
+              <a:t>Three ways of resolving ambiguous forms: the most frequent lemma, the language model, all candidates.</a:t>
             </a:r>
           </a:p>
           <a:p>
             <a:pPr algn="l">
               <a:spcAft>
-                <a:spcPts val="810"/>
+                <a:spcPts val="855"/>
               </a:spcAft>
             </a:pPr>
             <a:r>
-              <a:rPr sz="3000" b="1" i="0">
-                <a:solidFill>
-                  <a:srgbClr val="2A78D6"/>
-                </a:solidFill>
-                <a:latin typeface="Calibri"/>
-              </a:rPr>
-              <a:t>95%</a:t>
-            </a:r>
-            <a:r>
-              <a:rPr sz="1800" b="0">
+              <a:rPr sz="1900" b="1" i="0">
                 <a:solidFill>
                   <a:srgbClr val="0B0B0B"/>
                 </a:solidFill>
                 <a:latin typeface="Calibri"/>
               </a:rPr>
-              <a:t> of Graur’s words in the Kernel</a:t>
+              <a:t>Same picture every time: </a:t>
+            </a:r>
+            <a:r>
+              <a:rPr sz="1900" b="0">
+                <a:solidFill>
+                  <a:srgbClr val="0B0B0B"/>
+                </a:solidFill>
+                <a:latin typeface="Calibri"/>
+              </a:rPr>
+              <a:t>a Kernel of 29–36% and a MinSet of 7.5–10.9%.</a:t>
             </a:r>
           </a:p>
           <a:p>
             <a:pPr algn="l">
               <a:spcAft>
-                <a:spcPts val="810"/>
+                <a:spcPts val="855"/>
               </a:spcAft>
             </a:pPr>
             <a:r>
-              <a:rPr sz="1800" b="0" i="0">
-                <a:solidFill>
-                  <a:srgbClr val="52514E"/>
-                </a:solidFill>
-                <a:latin typeface="Calibri"/>
-              </a:rPr>
-              <a:t>chance: 33%</a:t>
-            </a:r>
-          </a:p>
-          <a:p>
-            <a:pPr algn="l">
-              <a:spcAft>
-                <a:spcPts val="810"/>
-              </a:spcAft>
-            </a:pPr>
-            <a:r>
-              <a:rPr sz="1800" b="0">
+              <a:rPr sz="1900" b="0">
                 <a:solidFill>
                   <a:srgbClr val="0B0B0B"/>
                 </a:solidFill>
                 <a:latin typeface="Calibri"/>
               </a:rPr>
-              <a:t>Graur’s most certain words are the most central: 97% in the Kernel, 49% in the MinSet (wider groups: 25%, 32%).</a:t>
+              <a:t>Correct lemmas reveal more reciprocal pairs.</a:t>
             </a:r>
           </a:p>
         </p:txBody>

</xml_diff>

<commit_message>
Add English Wiktionary (518,943 headwords) to the cross-linguistic comparison
Co-Authored-By: Claude Opus 5.5 <noreply@anthropic.com>
</commit_message>
<xml_diff>
--- a/slides/HiddenCore_ConsILR2026.pptx
+++ b/slides/HiddenCore_ConsILR2026.pptx
@@ -1356,7 +1356,7 @@
           <a:lstStyle/>
           <a:p>
             <a:r>
-              <a:t>Am aplicat exact aceeași procedură pe WordNet și pe Wiktionary-urile a 11 limbi. Peste tot, setul minim ocupă 10–16% din nucleu; în DEX ocupă 28%. Wiktionary-ul românesc seamănă cu DEX-ul, dar 70% din definițiile lui sunt copiate din DEX. Deci nucleul mare ține de felul în care definește DEX-ul, nu de faptul că româna e limbă romanică.</a:t>
+              <a:t>Am aplicat exact aceeași procedură pe WordNet și pe Wiktionary-urile a 11 limbi. Peste tot, setul minim ocupă 10–17% din nucleu; în DEX ocupă 28%. Wiktionary-ul românesc seamănă cu DEX-ul, dar 70% din definițiile lui sunt copiate din DEX. Deci nucleul mare ține de felul în care definește DEX-ul, nu de faptul că româna e limbă romanică.</a:t>
             </a:r>
           </a:p>
         </p:txBody>
@@ -11273,7 +11273,7 @@
         <p:spPr>
           <a:xfrm>
             <a:off x="457200" y="1600200"/>
-            <a:ext cx="7680960" cy="4544313"/>
+            <a:ext cx="7680960" cy="4812075"/>
           </a:xfrm>
           <a:prstGeom prst="rect">
             <a:avLst/>
@@ -11339,7 +11339,7 @@
                 </a:solidFill>
                 <a:latin typeface="Calibri"/>
               </a:rPr>
-              <a:t>10–16%</a:t>
+              <a:t>10–17%</a:t>
             </a:r>
             <a:r>
               <a:rPr sz="1700" b="0">

</xml_diff>

<commit_message>
Abstract and title from the co-author's version; replace the misleading are/ara example
Title: The Hidden Core of Romanian: A Graph-Theoretic Analysis of Dictionary Definitions.
Ambiguity is now illustrated with sare ('salt' / 'jumps') and fire, taken from DEX definitions.

Co-Authored-By: Claude Opus 5.5 <noreply@anthropic.com>
</commit_message>
<xml_diff>
--- a/slides/HiddenCore_ConsILR2026.pptx
+++ b/slides/HiddenCore_ConsILR2026.pptx
@@ -4607,7 +4607,7 @@
                 </a:solidFill>
                 <a:latin typeface="Calibri"/>
               </a:rPr>
-              <a:t>The words that define all others</a:t>
+              <a:t>A graph-theoretic analysis of dictionary definitions</a:t>
             </a:r>
           </a:p>
         </p:txBody>
@@ -10590,7 +10590,7 @@
                 </a:solidFill>
                 <a:latin typeface="Calibri"/>
               </a:rPr>
-              <a:t>are</a:t>
+              <a:t>sare</a:t>
             </a:r>
             <a:r>
               <a:rPr sz="2000" b="0">
@@ -10599,7 +10599,7 @@
                 </a:solidFill>
                 <a:latin typeface="Calibri"/>
               </a:rPr>
-              <a:t> → avea or ara?   </a:t>
+              <a:t> → sare ‘salt’ or sări ‘jump’?   </a:t>
             </a:r>
             <a:r>
               <a:rPr sz="2000" b="0" i="1">
@@ -10617,7 +10617,7 @@
                 </a:solidFill>
                 <a:latin typeface="Calibri"/>
               </a:rPr>
-              <a:t> → fi, fir or fire?</a:t>
+              <a:t> → fir ‘thread’, fire ‘nature’ or fi ‘be’?</a:t>
             </a:r>
           </a:p>
           <a:p>

</xml_diff>

<commit_message>
Full review of paper and slides: consistent ranges, figures redrawn at print size, reference fixes, cross-linguistic wording in slides
Co-Authored-By: Claude Opus 5.5 <noreply@anthropic.com>
</commit_message>
<xml_diff>
--- a/slides/HiddenCore_ConsILR2026.pptx
+++ b/slides/HiddenCore_ConsILR2026.pptx
@@ -4902,7 +4902,7 @@
         <p:spPr>
           <a:xfrm>
             <a:off x="548640" y="1691640"/>
-            <a:ext cx="7589520" cy="3095167"/>
+            <a:ext cx="7589520" cy="3352222"/>
           </a:xfrm>
           <a:prstGeom prst="rect">
             <a:avLst/>
@@ -6713,7 +6713,7 @@
         <p:spPr>
           <a:xfrm>
             <a:off x="548640" y="1691640"/>
-            <a:ext cx="7498079" cy="2659678"/>
+            <a:ext cx="7498079" cy="2784683"/>
           </a:xfrm>
           <a:prstGeom prst="rect">
             <a:avLst/>
@@ -7238,7 +7238,7 @@
                 </a:solidFill>
                 <a:latin typeface="Calibri"/>
               </a:rPr>
-              <a:t>Graur’s intuition is confirmed with data he never had, and placed in context.</a:t>
+              <a:t>Graur’s list is supported by data he never had, and placed in context.</a:t>
             </a:r>
           </a:p>
         </p:txBody>
@@ -7631,7 +7631,7 @@
                 </a:solidFill>
                 <a:latin typeface="Calibri"/>
               </a:rPr>
-              <a:t>The DEX is much more circular than English dictionaries; the cause is reciprocal (synonym) definition.</a:t>
+              <a:t>The DEX is much more circular than dictionaries of 11 other languages processed the same way; the cause is reciprocal (synonym) definition.</a:t>
             </a:r>
           </a:p>
         </p:txBody>
@@ -8091,7 +8091,7 @@
                 </a:solidFill>
                 <a:latin typeface="Calibri"/>
               </a:rPr>
-              <a:t>One dictionary, one edition, first senses only.</a:t>
+              <a:t>One Romanian dictionary (the Romanian Wiktionary copies it), one edition, first senses only.</a:t>
             </a:r>
           </a:p>
         </p:txBody>
@@ -8348,7 +8348,7 @@
                 </a:solidFill>
                 <a:latin typeface="Calibri"/>
               </a:rPr>
-              <a:t>About four times the English WordNet under the same procedure, mainly because the DEX defines words by synonyms.</a:t>
+              <a:t>In the DEX the MinSet takes 28% of the Kernel, against 10–17% in 11 other languages, mainly because the DEX defines words by synonyms.</a:t>
             </a:r>
           </a:p>
           <a:p>
@@ -8961,7 +8961,7 @@
                 </a:solidFill>
                 <a:latin typeface="Calibri"/>
               </a:rPr>
-              <a:t>Somewhere the circle must be broken by words learned from experience, not from definitions (the symbol grounding problem, Harnad 1990).</a:t>
+              <a:t>Somewhere the circle must be broken by words learned from experience (the symbol grounding problem, Harnad 1990).</a:t>
             </a:r>
           </a:p>
         </p:txBody>
@@ -9984,7 +9984,7 @@
                 </a:solidFill>
                 <a:latin typeface="Calibri"/>
               </a:rPr>
-              <a:t>(1957). We treat it as a historical hypothesis, not a gold standard.</a:t>
+              <a:t>(1957). We treat it as a historical expert hypothesis.</a:t>
             </a:r>
           </a:p>
         </p:txBody>
@@ -10891,7 +10891,7 @@
         <p:spPr>
           <a:xfrm>
             <a:off x="640080" y="1737360"/>
-            <a:ext cx="6675120" cy="3022502"/>
+            <a:ext cx="6675120" cy="3493759"/>
           </a:xfrm>
           <a:prstGeom prst="rect">
             <a:avLst/>
@@ -11177,7 +11177,7 @@
                 </a:solidFill>
                 <a:latin typeface="Calibri"/>
               </a:rPr>
-              <a:t>The DEX stands apart from dictionaries of 11 other languages</a:t>
+              <a:t>The DEX stands apart from 11 other languages</a:t>
             </a:r>
           </a:p>
         </p:txBody>
@@ -11272,8 +11272,8 @@
         </p:blipFill>
         <p:spPr>
           <a:xfrm>
-            <a:off x="457200" y="1600200"/>
-            <a:ext cx="7680960" cy="4812075"/>
+            <a:off x="457200" y="1463040"/>
+            <a:ext cx="6869303" cy="4846320"/>
           </a:xfrm>
           <a:prstGeom prst="rect">
             <a:avLst/>
@@ -11364,7 +11364,7 @@
                 </a:solidFill>
                 <a:latin typeface="Calibri"/>
               </a:rPr>
-              <a:t>Reciprocal pairs: 5–21 times more frequent in the DEX.</a:t>
+              <a:t>Reciprocal pairs: 5–20 times more frequent in the DEX.</a:t>
             </a:r>
           </a:p>
           <a:p>
@@ -12204,7 +12204,7 @@
         <p:spPr>
           <a:xfrm>
             <a:off x="640080" y="1737360"/>
-            <a:ext cx="6949440" cy="2745705"/>
+            <a:ext cx="6949440" cy="2959615"/>
           </a:xfrm>
           <a:prstGeom prst="rect">
             <a:avLst/>

</xml_diff>